<commit_message>
feat: AGP versioning, cost model, assurance packet, Terraform status doc
Formalizes the Aegis Governance Pattern (AGP) v1.0 as a versioned contract,
adds platform_core packaging with conformance test, monthly AWS cost model
(pilot vs production), auditor/GRC assurance cover sheet, honest Terraform &
GovCloud status, .gitattributes for binary safety, and README/CHANGELOG updates.

Co-Authored-By: Claude Opus 4.6 (1M context) <noreply@anthropic.com>
</commit_message>
<xml_diff>
--- a/aws_ai_governance_platform_gtm_deck.pptx
+++ b/aws_ai_governance_platform_gtm_deck.pptx
@@ -19,6 +19,7 @@
     <p:sldId id="268" r:id="rId14"/>
     <p:sldId id="269" r:id="rId15"/>
     <p:sldId id="270" r:id="rId16"/>
+    <p:sldId id="271" r:id="rId17"/>
   </p:sldIdLst>
   <p:notesMasterIdLst>
     <p:notesMasterId r:id="rId18"/>
@@ -2397,6 +2398,40 @@
           </a:p>
         </p:txBody>
       </p:sp>
+      <p:sp>
+        <p:nvSpPr>
+          <p:cNvPr id="11" name="TextBox 10"/>
+          <p:cNvSpPr txBox="1"/>
+          <p:nvPr/>
+        </p:nvSpPr>
+        <p:spPr>
+          <a:xfrm>
+            <a:off x="365760" y="6291072"/>
+            <a:ext cx="11460175" cy="457200"/>
+          </a:xfrm>
+          <a:prstGeom prst="rect">
+            <a:avLst/>
+          </a:prstGeom>
+          <a:noFill/>
+        </p:spPr>
+        <p:txBody>
+          <a:bodyPr wrap="square" tIns="0" bIns="0">
+            <a:spAutoFit/>
+          </a:bodyPr>
+          <a:lstStyle/>
+          <a:p>
+            <a:pPr algn="l"/>
+            <a:r>
+              <a:rPr sz="800" i="1">
+                <a:solidFill>
+                  <a:srgbClr val="879296"/>
+                </a:solidFill>
+              </a:rPr>
+              <a:t>Reference accelerator — not an AWS service, not AWS-supported software, not a compliance certification, and not production-ready for regulated data without customer-specific engineering, testing, authorization, and operational ownership.</a:t>
+            </a:r>
+          </a:p>
+        </p:txBody>
+      </p:sp>
     </p:spTree>
   </p:cSld>
   <p:clrMapOvr>
@@ -4081,7 +4116,7 @@
 </p:sld>
 </file>
 
-<file path=ppt/slides/slide13.xml><?xml version="1.0" encoding="utf-8"?>
+<file path=ppt/slides/slide12.xml><?xml version="1.0" encoding="utf-8"?>
 <p:sld xmlns:a="http://schemas.openxmlformats.org/drawingml/2006/main" xmlns:r="http://schemas.openxmlformats.org/officeDocument/2006/relationships" xmlns:p="http://schemas.openxmlformats.org/presentationml/2006/main">
   <p:cSld name="Slide 13">
     <p:bg>
@@ -5281,7 +5316,7 @@
 </p:sld>
 </file>
 
-<file path=ppt/slides/slide14.xml><?xml version="1.0" encoding="utf-8"?>
+<file path=ppt/slides/slide13.xml><?xml version="1.0" encoding="utf-8"?>
 <p:sld xmlns:a="http://schemas.openxmlformats.org/drawingml/2006/main" xmlns:r="http://schemas.openxmlformats.org/officeDocument/2006/relationships" xmlns:p="http://schemas.openxmlformats.org/presentationml/2006/main">
   <p:cSld name="Slide 14">
     <p:bg>
@@ -6009,7 +6044,7 @@
 </p:sld>
 </file>
 
-<file path=ppt/slides/slide15.xml><?xml version="1.0" encoding="utf-8"?>
+<file path=ppt/slides/slide14.xml><?xml version="1.0" encoding="utf-8"?>
 <p:sld xmlns:a="http://schemas.openxmlformats.org/drawingml/2006/main" xmlns:r="http://schemas.openxmlformats.org/officeDocument/2006/relationships" xmlns:p="http://schemas.openxmlformats.org/presentationml/2006/main">
   <p:cSld name="Slide 15">
     <p:bg>
@@ -6769,6 +6804,198 @@
               <a:t>AWS AI Governance Platform concept</a:t>
             </a:r>
             <a:endParaRPr lang="en-US" sz="650" dirty="0"/>
+          </a:p>
+        </p:txBody>
+      </p:sp>
+    </p:spTree>
+  </p:cSld>
+  <p:clrMapOvr>
+    <a:masterClrMapping/>
+  </p:clrMapOvr>
+</p:sld>
+</file>
+
+<file path=ppt/slides/slide15.xml><?xml version="1.0" encoding="utf-8"?>
+<p:sld xmlns:a="http://schemas.openxmlformats.org/drawingml/2006/main" xmlns:p="http://schemas.openxmlformats.org/presentationml/2006/main" xmlns:r="http://schemas.openxmlformats.org/officeDocument/2006/relationships">
+  <p:cSld>
+    <p:spTree>
+      <p:nvGrpSpPr>
+        <p:cNvPr id="1" name=""/>
+        <p:cNvGrpSpPr/>
+        <p:nvPr/>
+      </p:nvGrpSpPr>
+      <p:grpSpPr/>
+      <p:sp>
+        <p:nvSpPr>
+          <p:cNvPr id="2" name="Rectangle 1"/>
+          <p:cNvSpPr/>
+          <p:nvPr/>
+        </p:nvSpPr>
+        <p:spPr>
+          <a:xfrm>
+            <a:off x="0" y="0"/>
+            <a:ext cx="12191695" cy="6858000"/>
+          </a:xfrm>
+          <a:prstGeom prst="rect">
+            <a:avLst/>
+          </a:prstGeom>
+          <a:solidFill>
+            <a:srgbClr val="232F3E"/>
+          </a:solidFill>
+          <a:ln>
+            <a:noFill/>
+          </a:ln>
+          <a:effectLst/>
+        </p:spPr>
+        <p:style>
+          <a:lnRef idx="1">
+            <a:schemeClr val="accent1"/>
+          </a:lnRef>
+          <a:fillRef idx="3">
+            <a:schemeClr val="accent1"/>
+          </a:fillRef>
+          <a:effectRef idx="2">
+            <a:schemeClr val="accent1"/>
+          </a:effectRef>
+          <a:fontRef idx="minor">
+            <a:schemeClr val="lt1"/>
+          </a:fontRef>
+        </p:style>
+        <p:txBody>
+          <a:bodyPr rtlCol="0" anchor="ctr"/>
+          <a:lstStyle/>
+          <a:p>
+            <a:pPr algn="ctr"/>
+          </a:p>
+        </p:txBody>
+      </p:sp>
+      <p:sp>
+        <p:nvSpPr>
+          <p:cNvPr id="3" name="Rectangle 2"/>
+          <p:cNvSpPr/>
+          <p:nvPr/>
+        </p:nvSpPr>
+        <p:spPr>
+          <a:xfrm>
+            <a:off x="822960" y="1051560"/>
+            <a:ext cx="2011680" cy="82296"/>
+          </a:xfrm>
+          <a:prstGeom prst="rect">
+            <a:avLst/>
+          </a:prstGeom>
+          <a:solidFill>
+            <a:srgbClr val="FF9900"/>
+          </a:solidFill>
+          <a:ln>
+            <a:noFill/>
+          </a:ln>
+          <a:effectLst/>
+        </p:spPr>
+        <p:style>
+          <a:lnRef idx="1">
+            <a:schemeClr val="accent1"/>
+          </a:lnRef>
+          <a:fillRef idx="3">
+            <a:schemeClr val="accent1"/>
+          </a:fillRef>
+          <a:effectRef idx="2">
+            <a:schemeClr val="accent1"/>
+          </a:effectRef>
+          <a:fontRef idx="minor">
+            <a:schemeClr val="lt1"/>
+          </a:fontRef>
+        </p:style>
+        <p:txBody>
+          <a:bodyPr rtlCol="0" anchor="ctr"/>
+          <a:lstStyle/>
+          <a:p>
+            <a:pPr algn="ctr"/>
+          </a:p>
+        </p:txBody>
+      </p:sp>
+      <p:sp>
+        <p:nvSpPr>
+          <p:cNvPr id="4" name="TextBox 3"/>
+          <p:cNvSpPr txBox="1"/>
+          <p:nvPr/>
+        </p:nvSpPr>
+        <p:spPr>
+          <a:xfrm>
+            <a:off x="822960" y="1234440"/>
+            <a:ext cx="10545775" cy="914400"/>
+          </a:xfrm>
+          <a:prstGeom prst="rect">
+            <a:avLst/>
+          </a:prstGeom>
+          <a:noFill/>
+        </p:spPr>
+        <p:txBody>
+          <a:bodyPr wrap="square">
+            <a:spAutoFit/>
+          </a:bodyPr>
+          <a:lstStyle/>
+          <a:p>
+            <a:r>
+              <a:rPr sz="3400" b="1">
+                <a:solidFill>
+                  <a:srgbClr val="FFFFFF"/>
+                </a:solidFill>
+              </a:rPr>
+              <a:t>Disclaimer &amp; Shared Responsibility</a:t>
+            </a:r>
+          </a:p>
+        </p:txBody>
+      </p:sp>
+      <p:sp>
+        <p:nvSpPr>
+          <p:cNvPr id="5" name="TextBox 4"/>
+          <p:cNvSpPr txBox="1"/>
+          <p:nvPr/>
+        </p:nvSpPr>
+        <p:spPr>
+          <a:xfrm>
+            <a:off x="822960" y="2468880"/>
+            <a:ext cx="10545775" cy="3108960"/>
+          </a:xfrm>
+          <a:prstGeom prst="rect">
+            <a:avLst/>
+          </a:prstGeom>
+          <a:noFill/>
+        </p:spPr>
+        <p:txBody>
+          <a:bodyPr wrap="square">
+            <a:spAutoFit/>
+          </a:bodyPr>
+          <a:lstStyle/>
+          <a:p>
+            <a:pPr>
+              <a:spcAft>
+                <a:spcPts val="1200"/>
+              </a:spcAft>
+            </a:pPr>
+            <a:r>
+              <a:rPr sz="1600">
+                <a:solidFill>
+                  <a:srgbClr val="D5DBDB"/>
+                </a:solidFill>
+              </a:rPr>
+              <a:t>Reference accelerator — not an AWS service, not AWS-supported software, not a compliance certification, and not production-ready for regulated data without customer-specific engineering, testing, authorization, and operational ownership.</a:t>
+            </a:r>
+          </a:p>
+          <a:p>
+            <a:pPr>
+              <a:spcAft>
+                <a:spcPts val="1200"/>
+              </a:spcAft>
+            </a:pPr>
+            <a:r>
+              <a:rPr sz="1600">
+                <a:solidFill>
+                  <a:srgbClr val="D5DBDB"/>
+                </a:solidFill>
+              </a:rPr>
+              <a:t>Built on AWS; not affiliated with or endorsed by Amazon Web Services.</a:t>
+            </a:r>
           </a:p>
         </p:txBody>
       </p:sp>

</xml_diff>

<commit_message>
feat: AGP conformance register, run-cost model, operating model, release packet
Adds four root-level documents for customer/assessor readiness:
- AGP-CONFORMANCE.md: 8-control conformance map (module + test)
- AWS-RUN-COST.md: service-by-service cost framework with estimate template
- OPERATING-MODEL.md: RACI for the six CIO/CISO operational questions
- RELEASE-PACKET.md: defines what ships in a tagged release (SAST, SBOM, etc.)
Also updates README banner and GTM deck.

Co-Authored-By: Claude Opus 4.6 (1M context) <noreply@anthropic.com>
</commit_message>
<xml_diff>
--- a/aws_ai_governance_platform_gtm_deck.pptx
+++ b/aws_ai_governance_platform_gtm_deck.pptx
@@ -4,6 +4,9 @@
   <p:sldMasterIdLst>
     <p:sldMasterId id="2147483648" r:id="rId1"/>
   </p:sldMasterIdLst>
+  <p:notesMasterIdLst>
+    <p:notesMasterId r:id="rId17"/>
+  </p:notesMasterIdLst>
   <p:sldIdLst>
     <p:sldId id="256" r:id="rId2"/>
     <p:sldId id="257" r:id="rId3"/>
@@ -16,16 +19,13 @@
     <p:sldId id="264" r:id="rId10"/>
     <p:sldId id="265" r:id="rId11"/>
     <p:sldId id="266" r:id="rId12"/>
-    <p:sldId id="268" r:id="rId14"/>
-    <p:sldId id="269" r:id="rId15"/>
-    <p:sldId id="270" r:id="rId16"/>
-    <p:sldId id="271" r:id="rId17"/>
+    <p:sldId id="268" r:id="rId13"/>
+    <p:sldId id="269" r:id="rId14"/>
+    <p:sldId id="270" r:id="rId15"/>
+    <p:sldId id="271" r:id="rId16"/>
   </p:sldIdLst>
-  <p:notesMasterIdLst>
-    <p:notesMasterId r:id="rId18"/>
-  </p:notesMasterIdLst>
-  <p:sldSz cx="12191695" cy="6858000"/>
-  <p:notesSz cx="6858000" cy="12191695"/>
+  <p:sldSz cx="12192000" cy="6858000"/>
+  <p:notesSz cx="6858000" cy="12192000"/>
   <p:defaultTextStyle>
     <a:lvl1pPr marL="0" algn="l" defTabSz="914400" rtl="0" eaLnBrk="1" latinLnBrk="0" hangingPunct="1">
       <a:defRPr sz="1800" kern="1200">
@@ -118,6 +118,11 @@
       </a:defRPr>
     </a:lvl9pPr>
   </p:defaultTextStyle>
+  <p:extLst>
+    <p:ext uri="{EFAFB233-063F-42B5-8137-9DF3F51BA10A}">
+      <p15:sldGuideLst xmlns:p15="http://schemas.microsoft.com/office/powerpoint/2012/main"/>
+    </p:ext>
+  </p:extLst>
 </p:presentation>
 </file>
 
@@ -143,234 +148,10 @@
           <a:chExt cx="0" cy="0"/>
         </a:xfrm>
       </p:grpSpPr>
-      <p:sp>
-        <p:nvSpPr>
-          <p:cNvPr id="2" name="Header Placeholder 1"/>
-          <p:cNvSpPr>
-            <a:spLocks noGrp="1"/>
-          </p:cNvSpPr>
-          <p:nvPr>
-            <p:ph type="hdr" sz="quarter"/>
-          </p:nvPr>
-        </p:nvSpPr>
-        <p:spPr>
-          <a:xfrm>
-            <a:off x="0" y="0"/>
-            <a:ext cx="2971800" cy="458788"/>
-          </a:xfrm>
-          <a:prstGeom prst="rect">
-            <a:avLst/>
-          </a:prstGeom>
-        </p:spPr>
-        <p:txBody>
-          <a:bodyPr vert="horz" lIns="91440" tIns="45720" rIns="91440" bIns="45720" rtlCol="0"/>
-          <a:lstStyle>
-            <a:lvl1pPr algn="l">
-              <a:defRPr sz="1200"/>
-            </a:lvl1pPr>
-          </a:lstStyle>
-          <a:p>
-            <a:endParaRPr lang="en-US"/>
-          </a:p>
-        </p:txBody>
-      </p:sp>
-      <p:sp>
-        <p:nvSpPr>
-          <p:cNvPr id="3" name="Date Placeholder 2"/>
-          <p:cNvSpPr>
-            <a:spLocks noGrp="1"/>
-          </p:cNvSpPr>
-          <p:nvPr>
-            <p:ph type="dt" idx="1"/>
-          </p:nvPr>
-        </p:nvSpPr>
-        <p:spPr>
-          <a:xfrm>
-            <a:off x="3884613" y="0"/>
-            <a:ext cx="2971800" cy="458788"/>
-          </a:xfrm>
-          <a:prstGeom prst="rect">
-            <a:avLst/>
-          </a:prstGeom>
-        </p:spPr>
-        <p:txBody>
-          <a:bodyPr vert="horz" lIns="91440" tIns="45720" rIns="91440" bIns="45720" rtlCol="0"/>
-          <a:lstStyle>
-            <a:lvl1pPr algn="r">
-              <a:defRPr sz="1200"/>
-            </a:lvl1pPr>
-          </a:lstStyle>
-          <a:p>
-            <a:fld id="{5282F153-3F37-0F45-9E97-73ACFA13230C}" type="datetimeFigureOut">
-              <a:rPr lang="en-US"/>
-              <a:t>7/23/19</a:t>
-            </a:fld>
-            <a:endParaRPr lang="en-US"/>
-          </a:p>
-        </p:txBody>
-      </p:sp>
-      <p:sp>
-        <p:nvSpPr>
-          <p:cNvPr id="4" name="Slide Image Placeholder 3"/>
-          <p:cNvSpPr>
-            <a:spLocks noGrp="1" noRot="1" noChangeAspect="1"/>
-          </p:cNvSpPr>
-          <p:nvPr>
-            <p:ph type="sldImg" idx="2"/>
-          </p:nvPr>
-        </p:nvSpPr>
-        <p:spPr>
-          <a:xfrm>
-            <a:off x="685800" y="1143000"/>
-            <a:ext cx="5486400" cy="3086100"/>
-          </a:xfrm>
-          <a:prstGeom prst="rect">
-            <a:avLst/>
-          </a:prstGeom>
-          <a:noFill/>
-          <a:ln w="12700">
-            <a:solidFill>
-              <a:prstClr val="black"/>
-            </a:solidFill>
-          </a:ln>
-        </p:spPr>
-        <p:txBody>
-          <a:bodyPr vert="horz" lIns="91440" tIns="45720" rIns="91440" bIns="45720" rtlCol="0" anchor="ctr"/>
-          <a:lstStyle/>
-          <a:p>
-            <a:endParaRPr lang="en-US"/>
-          </a:p>
-        </p:txBody>
-      </p:sp>
-      <p:sp>
-        <p:nvSpPr>
-          <p:cNvPr id="5" name="Notes Placeholder 4"/>
-          <p:cNvSpPr>
-            <a:spLocks noGrp="1"/>
-          </p:cNvSpPr>
-          <p:nvPr>
-            <p:ph type="body" sz="quarter" idx="3"/>
-          </p:nvPr>
-        </p:nvSpPr>
-        <p:spPr>
-          <a:xfrm>
-            <a:off x="685800" y="4400550"/>
-            <a:ext cx="5486400" cy="3600450"/>
-          </a:xfrm>
-          <a:prstGeom prst="rect">
-            <a:avLst/>
-          </a:prstGeom>
-        </p:spPr>
-        <p:txBody>
-          <a:bodyPr vert="horz" lIns="91440" tIns="45720" rIns="91440" bIns="45720" rtlCol="0"/>
-          <a:lstStyle/>
-          <a:p>
-            <a:pPr lvl="0"/>
-            <a:r>
-              <a:rPr lang="en-US"/>
-              <a:t>Click to edit Master text styles</a:t>
-            </a:r>
-          </a:p>
-          <a:p>
-            <a:pPr lvl="1"/>
-            <a:r>
-              <a:rPr lang="en-US"/>
-              <a:t>Second level</a:t>
-            </a:r>
-          </a:p>
-          <a:p>
-            <a:pPr lvl="2"/>
-            <a:r>
-              <a:rPr lang="en-US"/>
-              <a:t>Third level</a:t>
-            </a:r>
-          </a:p>
-          <a:p>
-            <a:pPr lvl="3"/>
-            <a:r>
-              <a:rPr lang="en-US"/>
-              <a:t>Fourth level</a:t>
-            </a:r>
-          </a:p>
-          <a:p>
-            <a:pPr lvl="4"/>
-            <a:r>
-              <a:rPr lang="en-US"/>
-              <a:t>Fifth level</a:t>
-            </a:r>
-          </a:p>
-        </p:txBody>
-      </p:sp>
-      <p:sp>
-        <p:nvSpPr>
-          <p:cNvPr id="6" name="Footer Placeholder 5"/>
-          <p:cNvSpPr>
-            <a:spLocks noGrp="1"/>
-          </p:cNvSpPr>
-          <p:nvPr>
-            <p:ph type="ftr" sz="quarter" idx="4"/>
-          </p:nvPr>
-        </p:nvSpPr>
-        <p:spPr>
-          <a:xfrm>
-            <a:off x="0" y="8685213"/>
-            <a:ext cx="2971800" cy="458787"/>
-          </a:xfrm>
-          <a:prstGeom prst="rect">
-            <a:avLst/>
-          </a:prstGeom>
-        </p:spPr>
-        <p:txBody>
-          <a:bodyPr vert="horz" lIns="91440" tIns="45720" rIns="91440" bIns="45720" rtlCol="0" anchor="b"/>
-          <a:lstStyle>
-            <a:lvl1pPr algn="l">
-              <a:defRPr sz="1200"/>
-            </a:lvl1pPr>
-          </a:lstStyle>
-          <a:p>
-            <a:endParaRPr lang="en-US"/>
-          </a:p>
-        </p:txBody>
-      </p:sp>
-      <p:sp>
-        <p:nvSpPr>
-          <p:cNvPr id="7" name="Slide Number Placeholder 6"/>
-          <p:cNvSpPr>
-            <a:spLocks noGrp="1"/>
-          </p:cNvSpPr>
-          <p:nvPr>
-            <p:ph type="sldNum" sz="quarter" idx="5"/>
-          </p:nvPr>
-        </p:nvSpPr>
-        <p:spPr>
-          <a:xfrm>
-            <a:off x="3884613" y="8685213"/>
-            <a:ext cx="2971800" cy="458787"/>
-          </a:xfrm>
-          <a:prstGeom prst="rect">
-            <a:avLst/>
-          </a:prstGeom>
-        </p:spPr>
-        <p:txBody>
-          <a:bodyPr vert="horz" lIns="91440" tIns="45720" rIns="91440" bIns="45720" rtlCol="0" anchor="b"/>
-          <a:lstStyle>
-            <a:lvl1pPr algn="r">
-              <a:defRPr sz="1200"/>
-            </a:lvl1pPr>
-          </a:lstStyle>
-          <a:p>
-            <a:fld id="{CE5E9CC1-C706-0F49-92D6-E571CC5EEA8F}" type="slidenum">
-              <a:rPr lang="en-US"/>
-              <a:t>‹#›</a:t>
-            </a:fld>
-            <a:endParaRPr lang="en-US"/>
-          </a:p>
-        </p:txBody>
-      </p:sp>
     </p:spTree>
     <p:extLst>
       <p:ext uri="{BB962C8B-B14F-4D97-AF65-F5344CB8AC3E}">
-        <p14:creationId xmlns:p14="http://schemas.microsoft.com/office/powerpoint/2010/main" val="1024086991"/>
+        <p14:creationId xmlns:p14="http://schemas.microsoft.com/office/powerpoint/2010/main" val="3347009956"/>
       </p:ext>
     </p:extLst>
   </p:cSld>
@@ -520,7 +301,6 @@
 Repo reviewed: https://github.com/virtualryder/slg-ai-agents
 Key evidence: repo README states the agent is not the product; governance is. It also states this is a production-shaped accelerator, not an authorized production-ready system.</a:t>
             </a:r>
-            <a:endParaRPr lang="en-US" dirty="0"/>
           </a:p>
         </p:txBody>
       </p:sp>
@@ -611,7 +391,6 @@
 AWS documents InputTokenCount, OutputTokenCount, CacheReadInputTokens, CacheWriteInputTokens for quota and token monitoring: https://docs.aws.amazon.com/bedrock/latest/userguide/quotas-token-burndown.html
 Bedrock model invocation logging can deliver logs to CloudWatch or S3: https://docs.aws.amazon.com/bedrock/latest/userguide/model-invocation-logging.html</a:t>
             </a:r>
-            <a:endParaRPr lang="en-US" dirty="0"/>
           </a:p>
         </p:txBody>
       </p:sp>
@@ -703,7 +482,6 @@
 FBI CJIS Security Policy v6.0 is dated Dec. 27, 2024: https://le.fbi.gov/file-repository/cjis_security_policy_v6-0_20241227.pdf
 IRS Pub 1075 defines safeguards for Federal Tax Information: https://www.irs.gov/pub/irs-pdf/p1075.pdf</a:t>
             </a:r>
-            <a:endParaRPr lang="en-US" dirty="0"/>
           </a:p>
         </p:txBody>
       </p:sp>
@@ -725,6 +503,94 @@
             <a:fld id="{F7021451-1387-4CA6-816F-3879F97B5CBC}" type="slidenum">
               <a:rPr lang="en-US"/>
               <a:t>11</a:t>
+            </a:fld>
+            <a:endParaRPr lang="en-US"/>
+          </a:p>
+        </p:txBody>
+      </p:sp>
+    </p:spTree>
+    <p:extLst>
+      <p:ext uri="{BB962C8B-B14F-4D97-AF65-F5344CB8AC3E}">
+        <p14:creationId xmlns:p14="http://schemas.microsoft.com/office/powerpoint/2010/main" val="1024086991"/>
+      </p:ext>
+    </p:extLst>
+  </p:cSld>
+  <p:clrMapOvr>
+    <a:masterClrMapping/>
+  </p:clrMapOvr>
+</p:notes>
+</file>
+
+<file path=ppt/notesSlides/notesSlide12.xml><?xml version="1.0" encoding="utf-8"?>
+<p:notes xmlns:a="http://schemas.openxmlformats.org/drawingml/2006/main" xmlns:r="http://schemas.openxmlformats.org/officeDocument/2006/relationships" xmlns:p="http://schemas.openxmlformats.org/presentationml/2006/main">
+  <p:cSld>
+    <p:spTree>
+      <p:nvGrpSpPr>
+        <p:cNvPr id="1" name=""/>
+        <p:cNvGrpSpPr/>
+        <p:nvPr/>
+      </p:nvGrpSpPr>
+      <p:grpSpPr>
+        <a:xfrm>
+          <a:off x="0" y="0"/>
+          <a:ext cx="0" cy="0"/>
+          <a:chOff x="0" y="0"/>
+          <a:chExt cx="0" cy="0"/>
+        </a:xfrm>
+      </p:grpSpPr>
+      <p:sp>
+        <p:nvSpPr>
+          <p:cNvPr id="2" name="Slide Image Placeholder 1"/>
+          <p:cNvSpPr>
+            <a:spLocks noGrp="1" noRot="1" noChangeAspect="1"/>
+          </p:cNvSpPr>
+          <p:nvPr>
+            <p:ph type="sldImg"/>
+          </p:nvPr>
+        </p:nvSpPr>
+        <p:spPr/>
+      </p:sp>
+      <p:sp>
+        <p:nvSpPr>
+          <p:cNvPr id="3" name="Notes Placeholder 2"/>
+          <p:cNvSpPr>
+            <a:spLocks noGrp="1"/>
+          </p:cNvSpPr>
+          <p:nvPr>
+            <p:ph type="body" idx="1"/>
+          </p:nvPr>
+        </p:nvSpPr>
+        <p:spPr/>
+        <p:txBody>
+          <a:bodyPr/>
+          <a:lstStyle/>
+          <a:p>
+            <a:r>
+              <a:rPr lang="en-US" dirty="0"/>
+              <a:t>The phased plan is intentionally biased toward a low-blast-radius first agent. The existing SLG production-readiness document recommends Resident Services/311 or IT service desk before benefits/public safety.
+The first pilot must produce measurable value and evidence, not just a demo.</a:t>
+            </a:r>
+          </a:p>
+        </p:txBody>
+      </p:sp>
+      <p:sp>
+        <p:nvSpPr>
+          <p:cNvPr id="4" name="Slide Number Placeholder 3"/>
+          <p:cNvSpPr>
+            <a:spLocks noGrp="1"/>
+          </p:cNvSpPr>
+          <p:nvPr>
+            <p:ph type="sldNum" sz="quarter" idx="10"/>
+          </p:nvPr>
+        </p:nvSpPr>
+        <p:spPr/>
+        <p:txBody>
+          <a:bodyPr/>
+          <a:lstStyle/>
+          <a:p>
+            <a:fld id="{F7021451-1387-4CA6-816F-3879F97B5CBC}" type="slidenum">
+              <a:rPr lang="en-US"/>
+              <a:t>12</a:t>
             </a:fld>
             <a:endParaRPr lang="en-US"/>
           </a:p>
@@ -789,10 +655,9 @@
           <a:p>
             <a:r>
               <a:rPr lang="en-US" dirty="0"/>
-              <a:t>The phased plan is intentionally biased toward a low-blast-radius first agent. The existing SLG production-readiness document recommends Resident Services/311 or IT service desk before benefits/public safety.
-The first pilot must produce measurable value and evidence, not just a demo.</a:t>
-            </a:r>
-            <a:endParaRPr lang="en-US" dirty="0"/>
+              <a:t>This maps to the existing slg-ai-agents WOG GTM story, but broadens it from SLG to whole-of-enterprise governance.
+The key is to avoid overclaiming turnkey production readiness. Sell a governed pilot with a clear hardening path.</a:t>
+            </a:r>
           </a:p>
         </p:txBody>
       </p:sp>
@@ -878,10 +743,13 @@
           <a:p>
             <a:r>
               <a:rPr lang="en-US" dirty="0"/>
-              <a:t>This maps to the existing slg-ai-agents WOG GTM story, but broadens it from SLG to whole-of-enterprise governance.
-The key is to avoid overclaiming turnkey production readiness. Sell a governed pilot with a clear hardening path.</a:t>
-            </a:r>
-            <a:endParaRPr lang="en-US" dirty="0"/>
+              <a:t>AgentCore Gateway docs: https://docs.aws.amazon.com/bedrock-agentcore/latest/devguide/gateway.html
+AgentCore Identity docs: https://docs.aws.amazon.com/bedrock-agentcore/latest/devguide/identity.html
+Bedrock Guardrails docs: https://docs.aws.amazon.com/bedrock/latest/userguide/guardrails.html
+Bedrock PrivateLink docs: https://docs.aws.amazon.com/bedrock/latest/userguide/vpc-interface-endpoints.html
+AWS GovRAMP page: https://aws.amazon.com/compliance/govramp/
+Amazon Bedrock GovCloud FedRAMP High / DoD IL-4/5 announcement: https://aws.amazon.com/about-aws/whats-new/2025/05/amazon-bedrock-models-fedramp-high-dod-il-4-5-govcloud/</a:t>
+            </a:r>
           </a:p>
         </p:txBody>
       </p:sp>
@@ -903,99 +771,6 @@
             <a:fld id="{F7021451-1387-4CA6-816F-3879F97B5CBC}" type="slidenum">
               <a:rPr lang="en-US"/>
               <a:t>14</a:t>
-            </a:fld>
-            <a:endParaRPr lang="en-US"/>
-          </a:p>
-        </p:txBody>
-      </p:sp>
-    </p:spTree>
-    <p:extLst>
-      <p:ext uri="{BB962C8B-B14F-4D97-AF65-F5344CB8AC3E}">
-        <p14:creationId xmlns:p14="http://schemas.microsoft.com/office/powerpoint/2010/main" val="1024086991"/>
-      </p:ext>
-    </p:extLst>
-  </p:cSld>
-  <p:clrMapOvr>
-    <a:masterClrMapping/>
-  </p:clrMapOvr>
-</p:notes>
-</file>
-
-<file path=ppt/notesSlides/notesSlide15.xml><?xml version="1.0" encoding="utf-8"?>
-<p:notes xmlns:a="http://schemas.openxmlformats.org/drawingml/2006/main" xmlns:r="http://schemas.openxmlformats.org/officeDocument/2006/relationships" xmlns:p="http://schemas.openxmlformats.org/presentationml/2006/main">
-  <p:cSld>
-    <p:spTree>
-      <p:nvGrpSpPr>
-        <p:cNvPr id="1" name=""/>
-        <p:cNvGrpSpPr/>
-        <p:nvPr/>
-      </p:nvGrpSpPr>
-      <p:grpSpPr>
-        <a:xfrm>
-          <a:off x="0" y="0"/>
-          <a:ext cx="0" cy="0"/>
-          <a:chOff x="0" y="0"/>
-          <a:chExt cx="0" cy="0"/>
-        </a:xfrm>
-      </p:grpSpPr>
-      <p:sp>
-        <p:nvSpPr>
-          <p:cNvPr id="2" name="Slide Image Placeholder 1"/>
-          <p:cNvSpPr>
-            <a:spLocks noGrp="1" noRot="1" noChangeAspect="1"/>
-          </p:cNvSpPr>
-          <p:nvPr>
-            <p:ph type="sldImg"/>
-          </p:nvPr>
-        </p:nvSpPr>
-        <p:spPr/>
-      </p:sp>
-      <p:sp>
-        <p:nvSpPr>
-          <p:cNvPr id="3" name="Notes Placeholder 2"/>
-          <p:cNvSpPr>
-            <a:spLocks noGrp="1"/>
-          </p:cNvSpPr>
-          <p:nvPr>
-            <p:ph type="body" idx="1"/>
-          </p:nvPr>
-        </p:nvSpPr>
-        <p:spPr/>
-        <p:txBody>
-          <a:bodyPr/>
-          <a:lstStyle/>
-          <a:p>
-            <a:r>
-              <a:rPr lang="en-US" dirty="0"/>
-              <a:t>AgentCore Gateway docs: https://docs.aws.amazon.com/bedrock-agentcore/latest/devguide/gateway.html
-AgentCore Identity docs: https://docs.aws.amazon.com/bedrock-agentcore/latest/devguide/identity.html
-Bedrock Guardrails docs: https://docs.aws.amazon.com/bedrock/latest/userguide/guardrails.html
-Bedrock PrivateLink docs: https://docs.aws.amazon.com/bedrock/latest/userguide/vpc-interface-endpoints.html
-AWS GovRAMP page: https://aws.amazon.com/compliance/govramp/
-Amazon Bedrock GovCloud FedRAMP High / DoD IL-4/5 announcement: https://aws.amazon.com/about-aws/whats-new/2025/05/amazon-bedrock-models-fedramp-high-dod-il-4-5-govcloud/</a:t>
-            </a:r>
-            <a:endParaRPr lang="en-US" dirty="0"/>
-          </a:p>
-        </p:txBody>
-      </p:sp>
-      <p:sp>
-        <p:nvSpPr>
-          <p:cNvPr id="4" name="Slide Number Placeholder 3"/>
-          <p:cNvSpPr>
-            <a:spLocks noGrp="1"/>
-          </p:cNvSpPr>
-          <p:nvPr>
-            <p:ph type="sldNum" sz="quarter" idx="10"/>
-          </p:nvPr>
-        </p:nvSpPr>
-        <p:spPr/>
-        <p:txBody>
-          <a:bodyPr/>
-          <a:lstStyle/>
-          <a:p>
-            <a:fld id="{F7021451-1387-4CA6-816F-3879F97B5CBC}" type="slidenum">
-              <a:rPr lang="en-US"/>
-              <a:t>15</a:t>
             </a:fld>
             <a:endParaRPr lang="en-US"/>
           </a:p>
@@ -1063,7 +838,6 @@
               <a:t>The current slg-ai-agents repository explicitly frames governance as the product and agents as configurations; README and ENTERPRISE-PLATFORM.md support this direction.
 NASCIO 2026 ranks AI as a top state CIO priority; the repository cites NASCIO pilot/funding constraints in its current README and sources.</a:t>
             </a:r>
-            <a:endParaRPr lang="en-US" dirty="0"/>
           </a:p>
         </p:txBody>
       </p:sp>
@@ -1152,7 +926,6 @@
               <a:t>Talk track: a point solution gives the customer another AI app. The platform gives them a standard operating model for every agent.
 This maps to the SLG repo GTM story: one identity, one authorization model, one audit trail across agencies.</a:t>
             </a:r>
-            <a:endParaRPr lang="en-US" dirty="0"/>
           </a:p>
         </p:txBody>
       </p:sp>
@@ -1242,7 +1015,6 @@
 AWS Security Lake can collect CloudTrail, EKS audit, Route 53 resolver, Security Hub, VPC Flow Logs, and WAF logs: https://docs.aws.amazon.com/security-lake/latest/userguide/internal-sources.html
 S3 Object Lock provides WORM-style protection for retention/legal hold: https://docs.aws.amazon.com/AmazonS3/latest/userguide/object-lock.html</a:t>
             </a:r>
-            <a:endParaRPr lang="en-US" dirty="0"/>
           </a:p>
         </p:txBody>
       </p:sp>
@@ -1332,7 +1104,6 @@
 AgentCore Identity supports scoped on-behalf-of token exchange: https://docs.aws.amazon.com/bedrock-agentcore/latest/devguide/on-behalf-of-token-exchange.html
 Amazon Verified Permissions externalizes fine-grained authorization using Cedar: https://docs.aws.amazon.com/verifiedpermissions/latest/userguide/what-is-avp.html</a:t>
             </a:r>
-            <a:endParaRPr lang="en-US" dirty="0"/>
           </a:p>
         </p:txBody>
       </p:sp>
@@ -1421,7 +1192,6 @@
               <a:t>Improvement from slg-ai-agents: extract gov_platform and governance into a platform repo with strict contracts, then refactor current agents into add-on packages.
 The existing repo already includes governance, control mappings, a WoG platform, and production-readiness documents; those should become formal product modules, not just repo folders.</a:t>
             </a:r>
-            <a:endParaRPr lang="en-US" dirty="0"/>
           </a:p>
         </p:txBody>
       </p:sp>
@@ -1510,7 +1280,6 @@
               <a:t>This is the contract Claude Code should build toward. The current SLG repo has similar concepts but needs a formal package spec and CI gate for each new agent.
 Agent YAML should compile to infrastructure, policy, dashboards, and compliance evidence.</a:t>
             </a:r>
-            <a:endParaRPr lang="en-US" dirty="0"/>
           </a:p>
         </p:txBody>
       </p:sp>
@@ -1600,7 +1369,6 @@
 AgentCore Gateway provides governed tool access and supports MCP-compatible tools: https://docs.aws.amazon.com/bedrock-agentcore/latest/devguide/gateway.html
 AgentCore Identity supports scoped OBO tokens: https://docs.aws.amazon.com/bedrock-agentcore/latest/devguide/on-behalf-of-token-exchange.html</a:t>
             </a:r>
-            <a:endParaRPr lang="en-US" dirty="0"/>
           </a:p>
         </p:txBody>
       </p:sp>
@@ -1690,7 +1458,6 @@
 Bedrock Guardrails contextual grounding checks can detect hallucinations for summarization, paraphrasing, and QA when reference source and query are provided: https://docs.aws.amazon.com/bedrock/latest/userguide/guardrails-contextual-grounding-check.html
 Bedrock sensitive information filters can detect PII in prompts or responses, but documentation notes limitations for tool_use output parameters, so deterministic DLP must still run around tool calls: https://docs.aws.amazon.com/bedrock/latest/userguide/guardrails-sensitive-filters.html</a:t>
             </a:r>
-            <a:endParaRPr lang="en-US" dirty="0"/>
           </a:p>
         </p:txBody>
       </p:sp>
@@ -1763,6 +1530,11 @@
 <file path=ppt/slideMasters/slideMaster1.xml><?xml version="1.0" encoding="utf-8"?>
 <p:sldMaster xmlns:a="http://schemas.openxmlformats.org/drawingml/2006/main" xmlns:r="http://schemas.openxmlformats.org/officeDocument/2006/relationships" xmlns:p="http://schemas.openxmlformats.org/presentationml/2006/main">
   <p:cSld>
+    <p:bg>
+      <p:bgRef idx="1001">
+        <a:schemeClr val="bg1"/>
+      </p:bgRef>
+    </p:bg>
     <p:spTree>
       <p:nvGrpSpPr>
         <p:cNvPr id="1" name=""/>
@@ -2045,6 +1817,7 @@
         <a:solidFill>
           <a:srgbClr val="232F3E"/>
         </a:solidFill>
+        <a:effectLst/>
       </p:bgPr>
     </p:bg>
     <p:spTree>
@@ -2085,6 +1858,13 @@
             <a:prstDash val="solid"/>
           </a:ln>
         </p:spPr>
+        <p:txBody>
+          <a:bodyPr/>
+          <a:lstStyle/>
+          <a:p>
+            <a:endParaRPr lang="en-US"/>
+          </a:p>
+        </p:txBody>
       </p:sp>
       <p:sp>
         <p:nvSpPr>
@@ -2114,6 +1894,13 @@
             <a:prstDash val="solid"/>
           </a:ln>
         </p:spPr>
+        <p:txBody>
+          <a:bodyPr/>
+          <a:lstStyle/>
+          <a:p>
+            <a:endParaRPr lang="en-US"/>
+          </a:p>
+        </p:txBody>
       </p:sp>
       <p:sp>
         <p:nvSpPr>
@@ -2143,6 +1930,13 @@
             <a:prstDash val="solid"/>
           </a:ln>
         </p:spPr>
+        <p:txBody>
+          <a:bodyPr/>
+          <a:lstStyle/>
+          <a:p>
+            <a:endParaRPr lang="en-US"/>
+          </a:p>
+        </p:txBody>
       </p:sp>
       <p:sp>
         <p:nvSpPr>
@@ -2165,7 +1959,7 @@
           <a:bodyPr wrap="square" lIns="0" tIns="0" rIns="0" bIns="0" rtlCol="0" anchor="ctr"/>
           <a:lstStyle/>
           <a:p>
-            <a:pPr indent="0" marL="0">
+            <a:pPr marL="0" indent="0">
               <a:buNone/>
             </a:pPr>
             <a:r>
@@ -2182,7 +1976,7 @@
             <a:endParaRPr lang="en-US" sz="4200" dirty="0"/>
           </a:p>
           <a:p>
-            <a:pPr indent="0" marL="0">
+            <a:pPr marL="0" indent="0">
               <a:buNone/>
             </a:pPr>
             <a:r>
@@ -2221,7 +2015,7 @@
           <a:bodyPr wrap="square" lIns="0" tIns="0" rIns="0" bIns="0" rtlCol="0" anchor="ctr"/>
           <a:lstStyle/>
           <a:p>
-            <a:pPr indent="0" marL="0">
+            <a:pPr marL="0" indent="0">
               <a:buNone/>
             </a:pPr>
             <a:r>
@@ -2263,7 +2057,7 @@
           <a:bodyPr wrap="square" lIns="0" tIns="0" rIns="0" bIns="0" rtlCol="0" anchor="ctr"/>
           <a:lstStyle/>
           <a:p>
-            <a:pPr algn="ctr" indent="0" marL="0">
+            <a:pPr marL="0" indent="0" algn="ctr">
               <a:buNone/>
             </a:pPr>
             <a:r>
@@ -2305,7 +2099,7 @@
           <a:bodyPr wrap="square" lIns="0" tIns="0" rIns="0" bIns="0" rtlCol="0" anchor="ctr"/>
           <a:lstStyle/>
           <a:p>
-            <a:pPr algn="ctr" indent="0" marL="0">
+            <a:pPr marL="0" indent="0" algn="ctr">
               <a:buNone/>
             </a:pPr>
             <a:r>
@@ -2347,7 +2141,7 @@
           <a:bodyPr wrap="square" lIns="0" tIns="0" rIns="0" bIns="0" rtlCol="0" anchor="ctr"/>
           <a:lstStyle/>
           <a:p>
-            <a:pPr algn="ctr" indent="0" marL="0">
+            <a:pPr marL="0" indent="0" algn="ctr">
               <a:buNone/>
             </a:pPr>
             <a:r>
@@ -2370,7 +2164,7 @@
         </p:nvSpPr>
         <p:spPr>
           <a:xfrm>
-            <a:off x="731520" y="6172200"/>
+            <a:off x="455475" y="6057900"/>
             <a:ext cx="5486400" cy="228600"/>
           </a:xfrm>
           <a:prstGeom prst="rect">
@@ -2383,7 +2177,7 @@
           <a:bodyPr wrap="square" lIns="0" tIns="0" rIns="0" bIns="0" rtlCol="0" anchor="ctr"/>
           <a:lstStyle/>
           <a:p>
-            <a:pPr indent="0" marL="0">
+            <a:pPr marL="0" indent="0">
               <a:buNone/>
             </a:pPr>
             <a:r>
@@ -2448,6 +2242,7 @@
         <a:solidFill>
           <a:srgbClr val="F8FAFC"/>
         </a:solidFill>
+        <a:effectLst/>
       </p:bgPr>
     </p:bg>
     <p:spTree>
@@ -2488,6 +2283,13 @@
             <a:prstDash val="solid"/>
           </a:ln>
         </p:spPr>
+        <p:txBody>
+          <a:bodyPr/>
+          <a:lstStyle/>
+          <a:p>
+            <a:endParaRPr lang="en-US"/>
+          </a:p>
+        </p:txBody>
       </p:sp>
       <p:sp>
         <p:nvSpPr>
@@ -2510,7 +2312,7 @@
           <a:bodyPr wrap="square" rtlCol="0" anchor="ctr"/>
           <a:lstStyle/>
           <a:p>
-            <a:pPr indent="0" marL="0">
+            <a:pPr marL="0" indent="0">
               <a:buNone/>
             </a:pPr>
             <a:r>
@@ -2549,7 +2351,7 @@
           <a:bodyPr wrap="square" lIns="0" tIns="0" rIns="0" bIns="0" rtlCol="0" anchor="ctr"/>
           <a:lstStyle/>
           <a:p>
-            <a:pPr indent="0" marL="0">
+            <a:pPr marL="0" indent="0">
               <a:buNone/>
             </a:pPr>
             <a:r>
@@ -2596,7 +2398,7 @@
           </a:bodyPr>
           <a:lstStyle/>
           <a:p>
-            <a:pPr algn="l" indent="0" marL="0">
+            <a:pPr marL="0" indent="0" algn="l">
               <a:buNone/>
             </a:pPr>
             <a:r>
@@ -2640,7 +2442,7 @@
           </a:bodyPr>
           <a:lstStyle/>
           <a:p>
-            <a:pPr algn="l" indent="0" marL="0">
+            <a:pPr marL="0" indent="0" algn="l">
               <a:buNone/>
             </a:pPr>
             <a:r>
@@ -2679,6 +2481,13 @@
             <a:tailEnd type="triangle"/>
           </a:ln>
         </p:spPr>
+        <p:txBody>
+          <a:bodyPr/>
+          <a:lstStyle/>
+          <a:p>
+            <a:endParaRPr lang="en-US"/>
+          </a:p>
+        </p:txBody>
       </p:sp>
       <p:sp>
         <p:nvSpPr>
@@ -2709,7 +2518,7 @@
           </a:bodyPr>
           <a:lstStyle/>
           <a:p>
-            <a:pPr algn="l" indent="0" marL="0">
+            <a:pPr marL="0" indent="0" algn="l">
               <a:buNone/>
             </a:pPr>
             <a:r>
@@ -2753,7 +2562,7 @@
           </a:bodyPr>
           <a:lstStyle/>
           <a:p>
-            <a:pPr algn="l" indent="0" marL="0">
+            <a:pPr marL="0" indent="0" algn="l">
               <a:buNone/>
             </a:pPr>
             <a:r>
@@ -2792,6 +2601,13 @@
             <a:tailEnd type="triangle"/>
           </a:ln>
         </p:spPr>
+        <p:txBody>
+          <a:bodyPr/>
+          <a:lstStyle/>
+          <a:p>
+            <a:endParaRPr lang="en-US"/>
+          </a:p>
+        </p:txBody>
       </p:sp>
       <p:sp>
         <p:nvSpPr>
@@ -2822,7 +2638,7 @@
           </a:bodyPr>
           <a:lstStyle/>
           <a:p>
-            <a:pPr algn="l" indent="0" marL="0">
+            <a:pPr marL="0" indent="0" algn="l">
               <a:buNone/>
             </a:pPr>
             <a:r>
@@ -2866,7 +2682,7 @@
           </a:bodyPr>
           <a:lstStyle/>
           <a:p>
-            <a:pPr algn="l" indent="0" marL="0">
+            <a:pPr marL="0" indent="0" algn="l">
               <a:buNone/>
             </a:pPr>
             <a:r>
@@ -2905,6 +2721,13 @@
             <a:tailEnd type="triangle"/>
           </a:ln>
         </p:spPr>
+        <p:txBody>
+          <a:bodyPr/>
+          <a:lstStyle/>
+          <a:p>
+            <a:endParaRPr lang="en-US"/>
+          </a:p>
+        </p:txBody>
       </p:sp>
       <p:sp>
         <p:nvSpPr>
@@ -2935,7 +2758,7 @@
           </a:bodyPr>
           <a:lstStyle/>
           <a:p>
-            <a:pPr algn="l" indent="0" marL="0">
+            <a:pPr marL="0" indent="0" algn="l">
               <a:buNone/>
             </a:pPr>
             <a:r>
@@ -2979,7 +2802,7 @@
           </a:bodyPr>
           <a:lstStyle/>
           <a:p>
-            <a:pPr algn="l" indent="0" marL="0">
+            <a:pPr marL="0" indent="0" algn="l">
               <a:buNone/>
             </a:pPr>
             <a:r>
@@ -3015,7 +2838,7 @@
           <a:bodyPr wrap="square" lIns="0" tIns="0" rIns="0" bIns="0" rtlCol="0" anchor="ctr"/>
           <a:lstStyle/>
           <a:p>
-            <a:pPr indent="0" marL="0">
+            <a:pPr marL="0" indent="0">
               <a:buNone/>
             </a:pPr>
             <a:r>
@@ -3053,7 +2876,7 @@
           </a:bodyPr>
           <a:lstStyle/>
           <a:p>
-            <a:pPr indent="0" marL="0">
+            <a:pPr marL="0" indent="0">
               <a:buNone/>
             </a:pPr>
             <a:r>
@@ -3089,7 +2912,7 @@
           <a:bodyPr wrap="square" lIns="0" tIns="0" rIns="0" bIns="0" rtlCol="0" anchor="ctr"/>
           <a:lstStyle/>
           <a:p>
-            <a:pPr algn="ctr" indent="0" marL="0">
+            <a:pPr marL="0" indent="0" algn="ctr">
               <a:buNone/>
             </a:pPr>
             <a:r>
@@ -3125,7 +2948,7 @@
           <a:bodyPr wrap="square" lIns="0" tIns="0" rIns="0" bIns="0" rtlCol="0" anchor="ctr"/>
           <a:lstStyle/>
           <a:p>
-            <a:pPr indent="0" marL="0">
+            <a:pPr marL="0" indent="0">
               <a:buNone/>
             </a:pPr>
             <a:r>
@@ -3161,7 +2984,7 @@
           <a:bodyPr wrap="square" lIns="0" tIns="0" rIns="0" bIns="0" rtlCol="0" anchor="ctr"/>
           <a:lstStyle/>
           <a:p>
-            <a:pPr algn="r" indent="0" marL="0">
+            <a:pPr marL="0" indent="0" algn="r">
               <a:buNone/>
             </a:pPr>
             <a:r>
@@ -3192,6 +3015,7 @@
         <a:solidFill>
           <a:srgbClr val="F8FAFC"/>
         </a:solidFill>
+        <a:effectLst/>
       </p:bgPr>
     </p:bg>
     <p:spTree>
@@ -3232,6 +3056,13 @@
             <a:prstDash val="solid"/>
           </a:ln>
         </p:spPr>
+        <p:txBody>
+          <a:bodyPr/>
+          <a:lstStyle/>
+          <a:p>
+            <a:endParaRPr lang="en-US"/>
+          </a:p>
+        </p:txBody>
       </p:sp>
       <p:sp>
         <p:nvSpPr>
@@ -3254,7 +3085,7 @@
           <a:bodyPr wrap="square" rtlCol="0" anchor="ctr"/>
           <a:lstStyle/>
           <a:p>
-            <a:pPr indent="0" marL="0">
+            <a:pPr marL="0" indent="0">
               <a:buNone/>
             </a:pPr>
             <a:r>
@@ -3293,7 +3124,7 @@
           <a:bodyPr wrap="square" lIns="0" tIns="0" rIns="0" bIns="0" rtlCol="0" anchor="ctr"/>
           <a:lstStyle/>
           <a:p>
-            <a:pPr indent="0" marL="0">
+            <a:pPr marL="0" indent="0">
               <a:buNone/>
             </a:pPr>
             <a:r>
@@ -3337,6 +3168,13 @@
             <a:prstDash val="solid"/>
           </a:ln>
         </p:spPr>
+        <p:txBody>
+          <a:bodyPr/>
+          <a:lstStyle/>
+          <a:p>
+            <a:endParaRPr lang="en-US"/>
+          </a:p>
+        </p:txBody>
       </p:sp>
       <p:sp>
         <p:nvSpPr>
@@ -3359,7 +3197,7 @@
           <a:bodyPr wrap="square" lIns="0" tIns="0" rIns="0" bIns="0" rtlCol="0" anchor="ctr"/>
           <a:lstStyle/>
           <a:p>
-            <a:pPr algn="ctr" indent="0" marL="0">
+            <a:pPr marL="0" indent="0" algn="ctr">
               <a:buNone/>
             </a:pPr>
             <a:r>
@@ -3397,7 +3235,7 @@
           </a:bodyPr>
           <a:lstStyle/>
           <a:p>
-            <a:pPr algn="ctr" indent="0" marL="0">
+            <a:pPr marL="0" indent="0" algn="ctr">
               <a:buNone/>
             </a:pPr>
             <a:r>
@@ -3411,7 +3249,7 @@
             <a:endParaRPr lang="en-US" sz="950" dirty="0"/>
           </a:p>
           <a:p>
-            <a:pPr algn="ctr" indent="0" marL="0">
+            <a:pPr marL="0" indent="0" algn="ctr">
               <a:buNone/>
             </a:pPr>
             <a:r>
@@ -3425,7 +3263,7 @@
             <a:endParaRPr lang="en-US" sz="950" dirty="0"/>
           </a:p>
           <a:p>
-            <a:pPr algn="ctr" indent="0" marL="0">
+            <a:pPr marL="0" indent="0" algn="ctr">
               <a:buNone/>
             </a:pPr>
             <a:r>
@@ -3466,6 +3304,13 @@
             <a:prstDash val="solid"/>
           </a:ln>
         </p:spPr>
+        <p:txBody>
+          <a:bodyPr/>
+          <a:lstStyle/>
+          <a:p>
+            <a:endParaRPr lang="en-US"/>
+          </a:p>
+        </p:txBody>
       </p:sp>
       <p:sp>
         <p:nvSpPr>
@@ -3488,7 +3333,7 @@
           <a:bodyPr wrap="square" lIns="0" tIns="0" rIns="0" bIns="0" rtlCol="0" anchor="ctr"/>
           <a:lstStyle/>
           <a:p>
-            <a:pPr algn="ctr" indent="0" marL="0">
+            <a:pPr marL="0" indent="0" algn="ctr">
               <a:buNone/>
             </a:pPr>
             <a:r>
@@ -3526,7 +3371,7 @@
           </a:bodyPr>
           <a:lstStyle/>
           <a:p>
-            <a:pPr algn="ctr" indent="0" marL="0">
+            <a:pPr marL="0" indent="0" algn="ctr">
               <a:buNone/>
             </a:pPr>
             <a:r>
@@ -3540,7 +3385,7 @@
             <a:endParaRPr lang="en-US" sz="950" dirty="0"/>
           </a:p>
           <a:p>
-            <a:pPr algn="ctr" indent="0" marL="0">
+            <a:pPr marL="0" indent="0" algn="ctr">
               <a:buNone/>
             </a:pPr>
             <a:r>
@@ -3554,7 +3399,7 @@
             <a:endParaRPr lang="en-US" sz="950" dirty="0"/>
           </a:p>
           <a:p>
-            <a:pPr algn="ctr" indent="0" marL="0">
+            <a:pPr marL="0" indent="0" algn="ctr">
               <a:buNone/>
             </a:pPr>
             <a:r>
@@ -3595,6 +3440,13 @@
             <a:prstDash val="solid"/>
           </a:ln>
         </p:spPr>
+        <p:txBody>
+          <a:bodyPr/>
+          <a:lstStyle/>
+          <a:p>
+            <a:endParaRPr lang="en-US"/>
+          </a:p>
+        </p:txBody>
       </p:sp>
       <p:sp>
         <p:nvSpPr>
@@ -3617,7 +3469,7 @@
           <a:bodyPr wrap="square" lIns="0" tIns="0" rIns="0" bIns="0" rtlCol="0" anchor="ctr"/>
           <a:lstStyle/>
           <a:p>
-            <a:pPr algn="ctr" indent="0" marL="0">
+            <a:pPr marL="0" indent="0" algn="ctr">
               <a:buNone/>
             </a:pPr>
             <a:r>
@@ -3655,7 +3507,7 @@
           </a:bodyPr>
           <a:lstStyle/>
           <a:p>
-            <a:pPr algn="ctr" indent="0" marL="0">
+            <a:pPr marL="0" indent="0" algn="ctr">
               <a:buNone/>
             </a:pPr>
             <a:r>
@@ -3669,7 +3521,7 @@
             <a:endParaRPr lang="en-US" sz="950" dirty="0"/>
           </a:p>
           <a:p>
-            <a:pPr algn="ctr" indent="0" marL="0">
+            <a:pPr marL="0" indent="0" algn="ctr">
               <a:buNone/>
             </a:pPr>
             <a:r>
@@ -3683,7 +3535,7 @@
             <a:endParaRPr lang="en-US" sz="950" dirty="0"/>
           </a:p>
           <a:p>
-            <a:pPr algn="ctr" indent="0" marL="0">
+            <a:pPr marL="0" indent="0" algn="ctr">
               <a:buNone/>
             </a:pPr>
             <a:r>
@@ -3724,6 +3576,13 @@
             <a:prstDash val="solid"/>
           </a:ln>
         </p:spPr>
+        <p:txBody>
+          <a:bodyPr/>
+          <a:lstStyle/>
+          <a:p>
+            <a:endParaRPr lang="en-US"/>
+          </a:p>
+        </p:txBody>
       </p:sp>
       <p:sp>
         <p:nvSpPr>
@@ -3746,7 +3605,7 @@
           <a:bodyPr wrap="square" lIns="0" tIns="0" rIns="0" bIns="0" rtlCol="0" anchor="ctr"/>
           <a:lstStyle/>
           <a:p>
-            <a:pPr algn="ctr" indent="0" marL="0">
+            <a:pPr marL="0" indent="0" algn="ctr">
               <a:buNone/>
             </a:pPr>
             <a:r>
@@ -3784,7 +3643,7 @@
           </a:bodyPr>
           <a:lstStyle/>
           <a:p>
-            <a:pPr algn="ctr" indent="0" marL="0">
+            <a:pPr marL="0" indent="0" algn="ctr">
               <a:buNone/>
             </a:pPr>
             <a:r>
@@ -3798,7 +3657,7 @@
             <a:endParaRPr lang="en-US" sz="950" dirty="0"/>
           </a:p>
           <a:p>
-            <a:pPr algn="ctr" indent="0" marL="0">
+            <a:pPr marL="0" indent="0" algn="ctr">
               <a:buNone/>
             </a:pPr>
             <a:r>
@@ -3812,7 +3671,7 @@
             <a:endParaRPr lang="en-US" sz="950" dirty="0"/>
           </a:p>
           <a:p>
-            <a:pPr algn="ctr" indent="0" marL="0">
+            <a:pPr marL="0" indent="0" algn="ctr">
               <a:buNone/>
             </a:pPr>
             <a:r>
@@ -3853,6 +3712,13 @@
             <a:prstDash val="solid"/>
           </a:ln>
         </p:spPr>
+        <p:txBody>
+          <a:bodyPr/>
+          <a:lstStyle/>
+          <a:p>
+            <a:endParaRPr lang="en-US"/>
+          </a:p>
+        </p:txBody>
       </p:sp>
       <p:sp>
         <p:nvSpPr>
@@ -3875,7 +3741,7 @@
           <a:bodyPr wrap="square" lIns="0" tIns="0" rIns="0" bIns="0" rtlCol="0" anchor="ctr"/>
           <a:lstStyle/>
           <a:p>
-            <a:pPr algn="ctr" indent="0" marL="0">
+            <a:pPr marL="0" indent="0" algn="ctr">
               <a:buNone/>
             </a:pPr>
             <a:r>
@@ -3913,7 +3779,7 @@
           </a:bodyPr>
           <a:lstStyle/>
           <a:p>
-            <a:pPr algn="ctr" indent="0" marL="0">
+            <a:pPr marL="0" indent="0" algn="ctr">
               <a:buNone/>
             </a:pPr>
             <a:r>
@@ -3927,7 +3793,7 @@
             <a:endParaRPr lang="en-US" sz="950" dirty="0"/>
           </a:p>
           <a:p>
-            <a:pPr algn="ctr" indent="0" marL="0">
+            <a:pPr marL="0" indent="0" algn="ctr">
               <a:buNone/>
             </a:pPr>
             <a:r>
@@ -3941,7 +3807,7 @@
             <a:endParaRPr lang="en-US" sz="950" dirty="0"/>
           </a:p>
           <a:p>
-            <a:pPr algn="ctr" indent="0" marL="0">
+            <a:pPr marL="0" indent="0" algn="ctr">
               <a:buNone/>
             </a:pPr>
             <a:r>
@@ -3985,7 +3851,7 @@
           </a:bodyPr>
           <a:lstStyle/>
           <a:p>
-            <a:pPr algn="ctr" indent="0" marL="0">
+            <a:pPr marL="0" indent="0" algn="ctr">
               <a:buNone/>
             </a:pPr>
             <a:r>
@@ -4021,7 +3887,7 @@
           <a:bodyPr wrap="square" lIns="0" tIns="0" rIns="0" bIns="0" rtlCol="0" anchor="ctr"/>
           <a:lstStyle/>
           <a:p>
-            <a:pPr algn="ctr" indent="0" marL="0">
+            <a:pPr marL="0" indent="0" algn="ctr">
               <a:buNone/>
             </a:pPr>
             <a:r>
@@ -4057,7 +3923,7 @@
           <a:bodyPr wrap="square" lIns="0" tIns="0" rIns="0" bIns="0" rtlCol="0" anchor="ctr"/>
           <a:lstStyle/>
           <a:p>
-            <a:pPr indent="0" marL="0">
+            <a:pPr marL="0" indent="0">
               <a:buNone/>
             </a:pPr>
             <a:r>
@@ -4093,7 +3959,7 @@
           <a:bodyPr wrap="square" lIns="0" tIns="0" rIns="0" bIns="0" rtlCol="0" anchor="ctr"/>
           <a:lstStyle/>
           <a:p>
-            <a:pPr algn="r" indent="0" marL="0">
+            <a:pPr marL="0" indent="0" algn="r">
               <a:buNone/>
             </a:pPr>
             <a:r>
@@ -4124,6 +3990,7 @@
         <a:solidFill>
           <a:srgbClr val="F8FAFC"/>
         </a:solidFill>
+        <a:effectLst/>
       </p:bgPr>
     </p:bg>
     <p:spTree>
@@ -4164,6 +4031,13 @@
             <a:prstDash val="solid"/>
           </a:ln>
         </p:spPr>
+        <p:txBody>
+          <a:bodyPr/>
+          <a:lstStyle/>
+          <a:p>
+            <a:endParaRPr lang="en-US"/>
+          </a:p>
+        </p:txBody>
       </p:sp>
       <p:sp>
         <p:nvSpPr>
@@ -4186,7 +4060,7 @@
           <a:bodyPr wrap="square" rtlCol="0" anchor="ctr"/>
           <a:lstStyle/>
           <a:p>
-            <a:pPr indent="0" marL="0">
+            <a:pPr marL="0" indent="0">
               <a:buNone/>
             </a:pPr>
             <a:r>
@@ -4225,7 +4099,7 @@
           <a:bodyPr wrap="square" lIns="0" tIns="0" rIns="0" bIns="0" rtlCol="0" anchor="ctr"/>
           <a:lstStyle/>
           <a:p>
-            <a:pPr indent="0" marL="0">
+            <a:pPr marL="0" indent="0">
               <a:buNone/>
             </a:pPr>
             <a:r>
@@ -4267,6 +4141,13 @@
             <a:prstDash val="solid"/>
           </a:ln>
         </p:spPr>
+        <p:txBody>
+          <a:bodyPr/>
+          <a:lstStyle/>
+          <a:p>
+            <a:endParaRPr lang="en-US"/>
+          </a:p>
+        </p:txBody>
       </p:sp>
       <p:sp>
         <p:nvSpPr>
@@ -4289,7 +4170,7 @@
           <a:bodyPr wrap="square" lIns="0" tIns="0" rIns="0" bIns="0" rtlCol="0" anchor="ctr"/>
           <a:lstStyle/>
           <a:p>
-            <a:pPr algn="ctr" indent="0" marL="0">
+            <a:pPr marL="0" indent="0" algn="ctr">
               <a:buNone/>
             </a:pPr>
             <a:r>
@@ -4328,6 +4209,13 @@
             <a:tailEnd type="triangle"/>
           </a:ln>
         </p:spPr>
+        <p:txBody>
+          <a:bodyPr/>
+          <a:lstStyle/>
+          <a:p>
+            <a:endParaRPr lang="en-US"/>
+          </a:p>
+        </p:txBody>
       </p:sp>
       <p:sp>
         <p:nvSpPr>
@@ -4350,7 +4238,7 @@
           <a:bodyPr wrap="square" lIns="0" tIns="0" rIns="0" bIns="0" rtlCol="0" anchor="ctr"/>
           <a:lstStyle/>
           <a:p>
-            <a:pPr algn="ctr" indent="0" marL="0">
+            <a:pPr marL="0" indent="0" algn="ctr">
               <a:buNone/>
             </a:pPr>
             <a:r>
@@ -4388,7 +4276,7 @@
           </a:bodyPr>
           <a:lstStyle/>
           <a:p>
-            <a:pPr algn="ctr" indent="0" marL="0">
+            <a:pPr marL="0" indent="0" algn="ctr">
               <a:buNone/>
             </a:pPr>
             <a:r>
@@ -4427,6 +4315,13 @@
             <a:prstDash val="solid"/>
           </a:ln>
         </p:spPr>
+        <p:txBody>
+          <a:bodyPr/>
+          <a:lstStyle/>
+          <a:p>
+            <a:endParaRPr lang="en-US"/>
+          </a:p>
+        </p:txBody>
       </p:sp>
       <p:sp>
         <p:nvSpPr>
@@ -4449,7 +4344,7 @@
           <a:bodyPr wrap="square" lIns="0" tIns="0" rIns="0" bIns="0" rtlCol="0" anchor="ctr"/>
           <a:lstStyle/>
           <a:p>
-            <a:pPr algn="ctr" indent="0" marL="0">
+            <a:pPr marL="0" indent="0" algn="ctr">
               <a:buNone/>
             </a:pPr>
             <a:r>
@@ -4488,6 +4383,13 @@
             <a:tailEnd type="triangle"/>
           </a:ln>
         </p:spPr>
+        <p:txBody>
+          <a:bodyPr/>
+          <a:lstStyle/>
+          <a:p>
+            <a:endParaRPr lang="en-US"/>
+          </a:p>
+        </p:txBody>
       </p:sp>
       <p:sp>
         <p:nvSpPr>
@@ -4510,7 +4412,7 @@
           <a:bodyPr wrap="square" lIns="0" tIns="0" rIns="0" bIns="0" rtlCol="0" anchor="ctr"/>
           <a:lstStyle/>
           <a:p>
-            <a:pPr algn="ctr" indent="0" marL="0">
+            <a:pPr marL="0" indent="0" algn="ctr">
               <a:buNone/>
             </a:pPr>
             <a:r>
@@ -4548,7 +4450,7 @@
           </a:bodyPr>
           <a:lstStyle/>
           <a:p>
-            <a:pPr algn="ctr" indent="0" marL="0">
+            <a:pPr marL="0" indent="0" algn="ctr">
               <a:buNone/>
             </a:pPr>
             <a:r>
@@ -4587,6 +4489,13 @@
             <a:prstDash val="solid"/>
           </a:ln>
         </p:spPr>
+        <p:txBody>
+          <a:bodyPr/>
+          <a:lstStyle/>
+          <a:p>
+            <a:endParaRPr lang="en-US"/>
+          </a:p>
+        </p:txBody>
       </p:sp>
       <p:sp>
         <p:nvSpPr>
@@ -4609,7 +4518,7 @@
           <a:bodyPr wrap="square" lIns="0" tIns="0" rIns="0" bIns="0" rtlCol="0" anchor="ctr"/>
           <a:lstStyle/>
           <a:p>
-            <a:pPr algn="ctr" indent="0" marL="0">
+            <a:pPr marL="0" indent="0" algn="ctr">
               <a:buNone/>
             </a:pPr>
             <a:r>
@@ -4648,6 +4557,13 @@
             <a:tailEnd type="triangle"/>
           </a:ln>
         </p:spPr>
+        <p:txBody>
+          <a:bodyPr/>
+          <a:lstStyle/>
+          <a:p>
+            <a:endParaRPr lang="en-US"/>
+          </a:p>
+        </p:txBody>
       </p:sp>
       <p:sp>
         <p:nvSpPr>
@@ -4670,7 +4586,7 @@
           <a:bodyPr wrap="square" lIns="0" tIns="0" rIns="0" bIns="0" rtlCol="0" anchor="ctr"/>
           <a:lstStyle/>
           <a:p>
-            <a:pPr algn="ctr" indent="0" marL="0">
+            <a:pPr marL="0" indent="0" algn="ctr">
               <a:buNone/>
             </a:pPr>
             <a:r>
@@ -4708,7 +4624,7 @@
           </a:bodyPr>
           <a:lstStyle/>
           <a:p>
-            <a:pPr algn="ctr" indent="0" marL="0">
+            <a:pPr marL="0" indent="0" algn="ctr">
               <a:buNone/>
             </a:pPr>
             <a:r>
@@ -4747,6 +4663,13 @@
             <a:prstDash val="solid"/>
           </a:ln>
         </p:spPr>
+        <p:txBody>
+          <a:bodyPr/>
+          <a:lstStyle/>
+          <a:p>
+            <a:endParaRPr lang="en-US"/>
+          </a:p>
+        </p:txBody>
       </p:sp>
       <p:sp>
         <p:nvSpPr>
@@ -4769,7 +4692,7 @@
           <a:bodyPr wrap="square" lIns="0" tIns="0" rIns="0" bIns="0" rtlCol="0" anchor="ctr"/>
           <a:lstStyle/>
           <a:p>
-            <a:pPr algn="ctr" indent="0" marL="0">
+            <a:pPr marL="0" indent="0" algn="ctr">
               <a:buNone/>
             </a:pPr>
             <a:r>
@@ -4808,6 +4731,13 @@
             <a:tailEnd type="triangle"/>
           </a:ln>
         </p:spPr>
+        <p:txBody>
+          <a:bodyPr/>
+          <a:lstStyle/>
+          <a:p>
+            <a:endParaRPr lang="en-US"/>
+          </a:p>
+        </p:txBody>
       </p:sp>
       <p:sp>
         <p:nvSpPr>
@@ -4830,7 +4760,7 @@
           <a:bodyPr wrap="square" lIns="0" tIns="0" rIns="0" bIns="0" rtlCol="0" anchor="ctr"/>
           <a:lstStyle/>
           <a:p>
-            <a:pPr algn="ctr" indent="0" marL="0">
+            <a:pPr marL="0" indent="0" algn="ctr">
               <a:buNone/>
             </a:pPr>
             <a:r>
@@ -4868,7 +4798,7 @@
           </a:bodyPr>
           <a:lstStyle/>
           <a:p>
-            <a:pPr algn="ctr" indent="0" marL="0">
+            <a:pPr marL="0" indent="0" algn="ctr">
               <a:buNone/>
             </a:pPr>
             <a:r>
@@ -4907,6 +4837,13 @@
             <a:prstDash val="solid"/>
           </a:ln>
         </p:spPr>
+        <p:txBody>
+          <a:bodyPr/>
+          <a:lstStyle/>
+          <a:p>
+            <a:endParaRPr lang="en-US"/>
+          </a:p>
+        </p:txBody>
       </p:sp>
       <p:sp>
         <p:nvSpPr>
@@ -4929,7 +4866,7 @@
           <a:bodyPr wrap="square" lIns="0" tIns="0" rIns="0" bIns="0" rtlCol="0" anchor="ctr"/>
           <a:lstStyle/>
           <a:p>
-            <a:pPr algn="ctr" indent="0" marL="0">
+            <a:pPr marL="0" indent="0" algn="ctr">
               <a:buNone/>
             </a:pPr>
             <a:r>
@@ -4968,6 +4905,13 @@
             <a:tailEnd type="triangle"/>
           </a:ln>
         </p:spPr>
+        <p:txBody>
+          <a:bodyPr/>
+          <a:lstStyle/>
+          <a:p>
+            <a:endParaRPr lang="en-US"/>
+          </a:p>
+        </p:txBody>
       </p:sp>
       <p:sp>
         <p:nvSpPr>
@@ -4990,7 +4934,7 @@
           <a:bodyPr wrap="square" lIns="0" tIns="0" rIns="0" bIns="0" rtlCol="0" anchor="ctr"/>
           <a:lstStyle/>
           <a:p>
-            <a:pPr algn="ctr" indent="0" marL="0">
+            <a:pPr marL="0" indent="0" algn="ctr">
               <a:buNone/>
             </a:pPr>
             <a:r>
@@ -5028,7 +4972,7 @@
           </a:bodyPr>
           <a:lstStyle/>
           <a:p>
-            <a:pPr algn="ctr" indent="0" marL="0">
+            <a:pPr marL="0" indent="0" algn="ctr">
               <a:buNone/>
             </a:pPr>
             <a:r>
@@ -5067,6 +5011,13 @@
             <a:prstDash val="solid"/>
           </a:ln>
         </p:spPr>
+        <p:txBody>
+          <a:bodyPr/>
+          <a:lstStyle/>
+          <a:p>
+            <a:endParaRPr lang="en-US"/>
+          </a:p>
+        </p:txBody>
       </p:sp>
       <p:sp>
         <p:nvSpPr>
@@ -5089,7 +5040,7 @@
           <a:bodyPr wrap="square" lIns="0" tIns="0" rIns="0" bIns="0" rtlCol="0" anchor="ctr"/>
           <a:lstStyle/>
           <a:p>
-            <a:pPr algn="ctr" indent="0" marL="0">
+            <a:pPr marL="0" indent="0" algn="ctr">
               <a:buNone/>
             </a:pPr>
             <a:r>
@@ -5125,7 +5076,7 @@
           <a:bodyPr wrap="square" lIns="0" tIns="0" rIns="0" bIns="0" rtlCol="0" anchor="ctr"/>
           <a:lstStyle/>
           <a:p>
-            <a:pPr algn="ctr" indent="0" marL="0">
+            <a:pPr marL="0" indent="0" algn="ctr">
               <a:buNone/>
             </a:pPr>
             <a:r>
@@ -5163,7 +5114,7 @@
           </a:bodyPr>
           <a:lstStyle/>
           <a:p>
-            <a:pPr algn="ctr" indent="0" marL="0">
+            <a:pPr marL="0" indent="0" algn="ctr">
               <a:buNone/>
             </a:pPr>
             <a:r>
@@ -5207,7 +5158,7 @@
           </a:bodyPr>
           <a:lstStyle/>
           <a:p>
-            <a:pPr algn="ctr" indent="0" marL="0">
+            <a:pPr marL="0" indent="0" algn="ctr">
               <a:buNone/>
             </a:pPr>
             <a:r>
@@ -5221,7 +5172,7 @@
             <a:endParaRPr lang="en-US" sz="1300" dirty="0"/>
           </a:p>
           <a:p>
-            <a:pPr algn="ctr" indent="0" marL="0">
+            <a:pPr marL="0" indent="0" algn="ctr">
               <a:buNone/>
             </a:pPr>
             <a:r>
@@ -5257,7 +5208,7 @@
           <a:bodyPr wrap="square" lIns="0" tIns="0" rIns="0" bIns="0" rtlCol="0" anchor="ctr"/>
           <a:lstStyle/>
           <a:p>
-            <a:pPr indent="0" marL="0">
+            <a:pPr marL="0" indent="0">
               <a:buNone/>
             </a:pPr>
             <a:r>
@@ -5293,7 +5244,7 @@
           <a:bodyPr wrap="square" lIns="0" tIns="0" rIns="0" bIns="0" rtlCol="0" anchor="ctr"/>
           <a:lstStyle/>
           <a:p>
-            <a:pPr algn="r" indent="0" marL="0">
+            <a:pPr marL="0" indent="0" algn="r">
               <a:buNone/>
             </a:pPr>
             <a:r>
@@ -5324,6 +5275,7 @@
         <a:solidFill>
           <a:srgbClr val="F8FAFC"/>
         </a:solidFill>
+        <a:effectLst/>
       </p:bgPr>
     </p:bg>
     <p:spTree>
@@ -5364,6 +5316,13 @@
             <a:prstDash val="solid"/>
           </a:ln>
         </p:spPr>
+        <p:txBody>
+          <a:bodyPr/>
+          <a:lstStyle/>
+          <a:p>
+            <a:endParaRPr lang="en-US"/>
+          </a:p>
+        </p:txBody>
       </p:sp>
       <p:sp>
         <p:nvSpPr>
@@ -5386,7 +5345,7 @@
           <a:bodyPr wrap="square" rtlCol="0" anchor="ctr"/>
           <a:lstStyle/>
           <a:p>
-            <a:pPr indent="0" marL="0">
+            <a:pPr marL="0" indent="0">
               <a:buNone/>
             </a:pPr>
             <a:r>
@@ -5425,7 +5384,7 @@
           <a:bodyPr wrap="square" lIns="0" tIns="0" rIns="0" bIns="0" rtlCol="0" anchor="ctr"/>
           <a:lstStyle/>
           <a:p>
-            <a:pPr indent="0" marL="0">
+            <a:pPr marL="0" indent="0">
               <a:buNone/>
             </a:pPr>
             <a:r>
@@ -5472,7 +5431,7 @@
           </a:bodyPr>
           <a:lstStyle/>
           <a:p>
-            <a:pPr algn="l" indent="0" marL="0">
+            <a:pPr marL="0" indent="0" algn="l">
               <a:buNone/>
             </a:pPr>
             <a:r>
@@ -5516,7 +5475,7 @@
           </a:bodyPr>
           <a:lstStyle/>
           <a:p>
-            <a:pPr algn="l" indent="0" marL="0">
+            <a:pPr marL="0" indent="0" algn="l">
               <a:buNone/>
             </a:pPr>
             <a:r>
@@ -5555,6 +5514,13 @@
             <a:tailEnd type="triangle"/>
           </a:ln>
         </p:spPr>
+        <p:txBody>
+          <a:bodyPr/>
+          <a:lstStyle/>
+          <a:p>
+            <a:endParaRPr lang="en-US"/>
+          </a:p>
+        </p:txBody>
       </p:sp>
       <p:sp>
         <p:nvSpPr>
@@ -5585,7 +5551,7 @@
           </a:bodyPr>
           <a:lstStyle/>
           <a:p>
-            <a:pPr algn="l" indent="0" marL="0">
+            <a:pPr marL="0" indent="0" algn="l">
               <a:buNone/>
             </a:pPr>
             <a:r>
@@ -5629,7 +5595,7 @@
           </a:bodyPr>
           <a:lstStyle/>
           <a:p>
-            <a:pPr algn="l" indent="0" marL="0">
+            <a:pPr marL="0" indent="0" algn="l">
               <a:buNone/>
             </a:pPr>
             <a:r>
@@ -5668,6 +5634,13 @@
             <a:tailEnd type="triangle"/>
           </a:ln>
         </p:spPr>
+        <p:txBody>
+          <a:bodyPr/>
+          <a:lstStyle/>
+          <a:p>
+            <a:endParaRPr lang="en-US"/>
+          </a:p>
+        </p:txBody>
       </p:sp>
       <p:sp>
         <p:nvSpPr>
@@ -5698,7 +5671,7 @@
           </a:bodyPr>
           <a:lstStyle/>
           <a:p>
-            <a:pPr algn="l" indent="0" marL="0">
+            <a:pPr marL="0" indent="0" algn="l">
               <a:buNone/>
             </a:pPr>
             <a:r>
@@ -5742,7 +5715,7 @@
           </a:bodyPr>
           <a:lstStyle/>
           <a:p>
-            <a:pPr algn="l" indent="0" marL="0">
+            <a:pPr marL="0" indent="0" algn="l">
               <a:buNone/>
             </a:pPr>
             <a:r>
@@ -5781,6 +5754,13 @@
             <a:tailEnd type="triangle"/>
           </a:ln>
         </p:spPr>
+        <p:txBody>
+          <a:bodyPr/>
+          <a:lstStyle/>
+          <a:p>
+            <a:endParaRPr lang="en-US"/>
+          </a:p>
+        </p:txBody>
       </p:sp>
       <p:sp>
         <p:nvSpPr>
@@ -5811,7 +5791,7 @@
           </a:bodyPr>
           <a:lstStyle/>
           <a:p>
-            <a:pPr algn="l" indent="0" marL="0">
+            <a:pPr marL="0" indent="0" algn="l">
               <a:buNone/>
             </a:pPr>
             <a:r>
@@ -5855,7 +5835,7 @@
           </a:bodyPr>
           <a:lstStyle/>
           <a:p>
-            <a:pPr algn="l" indent="0" marL="0">
+            <a:pPr marL="0" indent="0" algn="l">
               <a:buNone/>
             </a:pPr>
             <a:r>
@@ -5899,7 +5879,7 @@
           </a:bodyPr>
           <a:lstStyle/>
           <a:p>
-            <a:pPr algn="ctr" indent="0" marL="0">
+            <a:pPr marL="0" indent="0" algn="ctr">
               <a:buNone/>
             </a:pPr>
             <a:r>
@@ -5913,7 +5893,7 @@
             <a:endParaRPr lang="en-US" sz="1160" dirty="0"/>
           </a:p>
           <a:p>
-            <a:pPr algn="ctr" indent="0" marL="0">
+            <a:pPr marL="0" indent="0" algn="ctr">
               <a:buNone/>
             </a:pPr>
             <a:r>
@@ -5949,7 +5929,7 @@
           <a:bodyPr wrap="square" lIns="0" tIns="0" rIns="0" bIns="0" rtlCol="0" anchor="ctr"/>
           <a:lstStyle/>
           <a:p>
-            <a:pPr algn="ctr" indent="0" marL="0">
+            <a:pPr marL="0" indent="0" algn="ctr">
               <a:buNone/>
             </a:pPr>
             <a:r>
@@ -5985,7 +5965,7 @@
           <a:bodyPr wrap="square" lIns="0" tIns="0" rIns="0" bIns="0" rtlCol="0" anchor="ctr"/>
           <a:lstStyle/>
           <a:p>
-            <a:pPr indent="0" marL="0">
+            <a:pPr marL="0" indent="0">
               <a:buNone/>
             </a:pPr>
             <a:r>
@@ -6021,7 +6001,7 @@
           <a:bodyPr wrap="square" lIns="0" tIns="0" rIns="0" bIns="0" rtlCol="0" anchor="ctr"/>
           <a:lstStyle/>
           <a:p>
-            <a:pPr algn="r" indent="0" marL="0">
+            <a:pPr marL="0" indent="0" algn="r">
               <a:buNone/>
             </a:pPr>
             <a:r>
@@ -6052,6 +6032,7 @@
         <a:solidFill>
           <a:srgbClr val="F8FAFC"/>
         </a:solidFill>
+        <a:effectLst/>
       </p:bgPr>
     </p:bg>
     <p:spTree>
@@ -6092,6 +6073,13 @@
             <a:prstDash val="solid"/>
           </a:ln>
         </p:spPr>
+        <p:txBody>
+          <a:bodyPr/>
+          <a:lstStyle/>
+          <a:p>
+            <a:endParaRPr lang="en-US"/>
+          </a:p>
+        </p:txBody>
       </p:sp>
       <p:sp>
         <p:nvSpPr>
@@ -6114,7 +6102,7 @@
           <a:bodyPr wrap="square" rtlCol="0" anchor="ctr"/>
           <a:lstStyle/>
           <a:p>
-            <a:pPr indent="0" marL="0">
+            <a:pPr marL="0" indent="0">
               <a:buNone/>
             </a:pPr>
             <a:r>
@@ -6153,7 +6141,7 @@
           <a:bodyPr wrap="square" lIns="0" tIns="0" rIns="0" bIns="0" rtlCol="0" anchor="ctr"/>
           <a:lstStyle/>
           <a:p>
-            <a:pPr indent="0" marL="0">
+            <a:pPr marL="0" indent="0">
               <a:buNone/>
             </a:pPr>
             <a:r>
@@ -6200,7 +6188,7 @@
           </a:bodyPr>
           <a:lstStyle/>
           <a:p>
-            <a:pPr algn="l" indent="0" marL="0">
+            <a:pPr marL="0" indent="0" algn="l">
               <a:buNone/>
             </a:pPr>
             <a:r>
@@ -6244,7 +6232,7 @@
           </a:bodyPr>
           <a:lstStyle/>
           <a:p>
-            <a:pPr algn="l" indent="0" marL="0">
+            <a:pPr marL="0" indent="0" algn="l">
               <a:buNone/>
             </a:pPr>
             <a:r>
@@ -6288,7 +6276,7 @@
           </a:bodyPr>
           <a:lstStyle/>
           <a:p>
-            <a:pPr algn="l" indent="0" marL="0">
+            <a:pPr marL="0" indent="0" algn="l">
               <a:buNone/>
             </a:pPr>
             <a:r>
@@ -6332,7 +6320,7 @@
           </a:bodyPr>
           <a:lstStyle/>
           <a:p>
-            <a:pPr algn="l" indent="0" marL="0">
+            <a:pPr marL="0" indent="0" algn="l">
               <a:buNone/>
             </a:pPr>
             <a:r>
@@ -6376,7 +6364,7 @@
           </a:bodyPr>
           <a:lstStyle/>
           <a:p>
-            <a:pPr algn="l" indent="0" marL="0">
+            <a:pPr marL="0" indent="0" algn="l">
               <a:buNone/>
             </a:pPr>
             <a:r>
@@ -6420,7 +6408,7 @@
           </a:bodyPr>
           <a:lstStyle/>
           <a:p>
-            <a:pPr algn="l" indent="0" marL="0">
+            <a:pPr marL="0" indent="0" algn="l">
               <a:buNone/>
             </a:pPr>
             <a:r>
@@ -6464,7 +6452,7 @@
           </a:bodyPr>
           <a:lstStyle/>
           <a:p>
-            <a:pPr algn="l" indent="0" marL="0">
+            <a:pPr marL="0" indent="0" algn="l">
               <a:buNone/>
             </a:pPr>
             <a:r>
@@ -6508,7 +6496,7 @@
           </a:bodyPr>
           <a:lstStyle/>
           <a:p>
-            <a:pPr algn="l" indent="0" marL="0">
+            <a:pPr marL="0" indent="0" algn="l">
               <a:buNone/>
             </a:pPr>
             <a:r>
@@ -6552,7 +6540,7 @@
           </a:bodyPr>
           <a:lstStyle/>
           <a:p>
-            <a:pPr algn="l" indent="0" marL="0">
+            <a:pPr marL="0" indent="0" algn="l">
               <a:buNone/>
             </a:pPr>
             <a:r>
@@ -6596,7 +6584,7 @@
           </a:bodyPr>
           <a:lstStyle/>
           <a:p>
-            <a:pPr algn="l" indent="0" marL="0">
+            <a:pPr marL="0" indent="0" algn="l">
               <a:buNone/>
             </a:pPr>
             <a:r>
@@ -6640,7 +6628,7 @@
           </a:bodyPr>
           <a:lstStyle/>
           <a:p>
-            <a:pPr algn="l" indent="0" marL="0">
+            <a:pPr marL="0" indent="0" algn="l">
               <a:buNone/>
             </a:pPr>
             <a:r>
@@ -6684,7 +6672,7 @@
           </a:bodyPr>
           <a:lstStyle/>
           <a:p>
-            <a:pPr algn="l" indent="0" marL="0">
+            <a:pPr marL="0" indent="0" algn="l">
               <a:buNone/>
             </a:pPr>
             <a:r>
@@ -6720,7 +6708,7 @@
           <a:bodyPr wrap="square" lIns="0" tIns="0" rIns="0" bIns="0" rtlCol="0" anchor="ctr"/>
           <a:lstStyle/>
           <a:p>
-            <a:pPr algn="ctr" indent="0" marL="0">
+            <a:pPr marL="0" indent="0" algn="ctr">
               <a:buNone/>
             </a:pPr>
             <a:r>
@@ -6756,7 +6744,7 @@
           <a:bodyPr wrap="square" lIns="0" tIns="0" rIns="0" bIns="0" rtlCol="0" anchor="ctr"/>
           <a:lstStyle/>
           <a:p>
-            <a:pPr indent="0" marL="0">
+            <a:pPr marL="0" indent="0">
               <a:buNone/>
             </a:pPr>
             <a:r>
@@ -6792,7 +6780,7 @@
           <a:bodyPr wrap="square" lIns="0" tIns="0" rIns="0" bIns="0" rtlCol="0" anchor="ctr"/>
           <a:lstStyle/>
           <a:p>
-            <a:pPr algn="r" indent="0" marL="0">
+            <a:pPr marL="0" indent="0" algn="r">
               <a:buNone/>
             </a:pPr>
             <a:r>
@@ -6816,7 +6804,7 @@
 </file>
 
 <file path=ppt/slides/slide15.xml><?xml version="1.0" encoding="utf-8"?>
-<p:sld xmlns:a="http://schemas.openxmlformats.org/drawingml/2006/main" xmlns:p="http://schemas.openxmlformats.org/presentationml/2006/main" xmlns:r="http://schemas.openxmlformats.org/officeDocument/2006/relationships">
+<p:sld xmlns:a="http://schemas.openxmlformats.org/drawingml/2006/main" xmlns:r="http://schemas.openxmlformats.org/officeDocument/2006/relationships" xmlns:p="http://schemas.openxmlformats.org/presentationml/2006/main">
   <p:cSld>
     <p:spTree>
       <p:nvGrpSpPr>
@@ -6824,7 +6812,14 @@
         <p:cNvGrpSpPr/>
         <p:nvPr/>
       </p:nvGrpSpPr>
-      <p:grpSpPr/>
+      <p:grpSpPr>
+        <a:xfrm>
+          <a:off x="0" y="0"/>
+          <a:ext cx="0" cy="0"/>
+          <a:chOff x="0" y="0"/>
+          <a:chExt cx="0" cy="0"/>
+        </a:xfrm>
+      </p:grpSpPr>
       <p:sp>
         <p:nvSpPr>
           <p:cNvPr id="2" name="Rectangle 1"/>
@@ -6866,6 +6861,7 @@
           <a:lstStyle/>
           <a:p>
             <a:pPr algn="ctr"/>
+            <a:endParaRPr/>
           </a:p>
         </p:txBody>
       </p:sp>
@@ -6910,6 +6906,7 @@
           <a:lstStyle/>
           <a:p>
             <a:pPr algn="ctr"/>
+            <a:endParaRPr/>
           </a:p>
         </p:txBody>
       </p:sp>
@@ -7015,6 +7012,7 @@
         <a:solidFill>
           <a:srgbClr val="F8FAFC"/>
         </a:solidFill>
+        <a:effectLst/>
       </p:bgPr>
     </p:bg>
     <p:spTree>
@@ -7055,6 +7053,13 @@
             <a:prstDash val="solid"/>
           </a:ln>
         </p:spPr>
+        <p:txBody>
+          <a:bodyPr/>
+          <a:lstStyle/>
+          <a:p>
+            <a:endParaRPr lang="en-US"/>
+          </a:p>
+        </p:txBody>
       </p:sp>
       <p:sp>
         <p:nvSpPr>
@@ -7077,7 +7082,7 @@
           <a:bodyPr wrap="square" rtlCol="0" anchor="ctr"/>
           <a:lstStyle/>
           <a:p>
-            <a:pPr indent="0" marL="0">
+            <a:pPr marL="0" indent="0">
               <a:buNone/>
             </a:pPr>
             <a:r>
@@ -7116,7 +7121,7 @@
           <a:bodyPr wrap="square" lIns="0" tIns="0" rIns="0" bIns="0" rtlCol="0" anchor="ctr"/>
           <a:lstStyle/>
           <a:p>
-            <a:pPr indent="0" marL="0">
+            <a:pPr marL="0" indent="0">
               <a:buNone/>
             </a:pPr>
             <a:r>
@@ -7163,7 +7168,7 @@
           </a:bodyPr>
           <a:lstStyle/>
           <a:p>
-            <a:pPr algn="l" indent="0" marL="0">
+            <a:pPr marL="0" indent="0" algn="l">
               <a:buNone/>
             </a:pPr>
             <a:r>
@@ -7207,7 +7212,7 @@
           </a:bodyPr>
           <a:lstStyle/>
           <a:p>
-            <a:pPr algn="l" indent="0" marL="0">
+            <a:pPr marL="0" indent="0" algn="l">
               <a:buNone/>
             </a:pPr>
             <a:r>
@@ -7251,7 +7256,7 @@
           </a:bodyPr>
           <a:lstStyle/>
           <a:p>
-            <a:pPr algn="l" indent="0" marL="0">
+            <a:pPr marL="0" indent="0" algn="l">
               <a:buNone/>
             </a:pPr>
             <a:r>
@@ -7295,7 +7300,7 @@
           </a:bodyPr>
           <a:lstStyle/>
           <a:p>
-            <a:pPr algn="l" indent="0" marL="0">
+            <a:pPr marL="0" indent="0" algn="l">
               <a:buNone/>
             </a:pPr>
             <a:r>
@@ -7339,7 +7344,7 @@
           </a:bodyPr>
           <a:lstStyle/>
           <a:p>
-            <a:pPr algn="l" indent="0" marL="0">
+            <a:pPr marL="0" indent="0" algn="l">
               <a:buNone/>
             </a:pPr>
             <a:r>
@@ -7383,7 +7388,7 @@
           </a:bodyPr>
           <a:lstStyle/>
           <a:p>
-            <a:pPr algn="l" indent="0" marL="0">
+            <a:pPr marL="0" indent="0" algn="l">
               <a:buNone/>
             </a:pPr>
             <a:r>
@@ -7427,7 +7432,7 @@
           </a:bodyPr>
           <a:lstStyle/>
           <a:p>
-            <a:pPr algn="l" indent="0" marL="0">
+            <a:pPr marL="0" indent="0" algn="l">
               <a:buNone/>
             </a:pPr>
             <a:r>
@@ -7471,7 +7476,7 @@
           </a:bodyPr>
           <a:lstStyle/>
           <a:p>
-            <a:pPr algn="l" indent="0" marL="0">
+            <a:pPr marL="0" indent="0" algn="l">
               <a:buNone/>
             </a:pPr>
             <a:r>
@@ -7513,7 +7518,7 @@
           <a:bodyPr wrap="square" lIns="0" tIns="0" rIns="0" bIns="0" rtlCol="0" anchor="ctr"/>
           <a:lstStyle/>
           <a:p>
-            <a:pPr algn="ctr" indent="0" marL="0">
+            <a:pPr marL="0" indent="0" algn="ctr">
               <a:buNone/>
             </a:pPr>
             <a:r>
@@ -7549,7 +7554,7 @@
           <a:bodyPr wrap="square" lIns="0" tIns="0" rIns="0" bIns="0" rtlCol="0" anchor="ctr"/>
           <a:lstStyle/>
           <a:p>
-            <a:pPr algn="ctr" indent="0" marL="0">
+            <a:pPr marL="0" indent="0" algn="ctr">
               <a:buNone/>
             </a:pPr>
             <a:r>
@@ -7585,7 +7590,7 @@
           <a:bodyPr wrap="square" lIns="0" tIns="0" rIns="0" bIns="0" rtlCol="0" anchor="ctr"/>
           <a:lstStyle/>
           <a:p>
-            <a:pPr indent="0" marL="0">
+            <a:pPr marL="0" indent="0">
               <a:buNone/>
             </a:pPr>
             <a:r>
@@ -7621,7 +7626,7 @@
           <a:bodyPr wrap="square" lIns="0" tIns="0" rIns="0" bIns="0" rtlCol="0" anchor="ctr"/>
           <a:lstStyle/>
           <a:p>
-            <a:pPr algn="r" indent="0" marL="0">
+            <a:pPr marL="0" indent="0" algn="r">
               <a:buNone/>
             </a:pPr>
             <a:r>
@@ -7652,6 +7657,7 @@
         <a:solidFill>
           <a:srgbClr val="F8FAFC"/>
         </a:solidFill>
+        <a:effectLst/>
       </p:bgPr>
     </p:bg>
     <p:spTree>
@@ -7692,6 +7698,13 @@
             <a:prstDash val="solid"/>
           </a:ln>
         </p:spPr>
+        <p:txBody>
+          <a:bodyPr/>
+          <a:lstStyle/>
+          <a:p>
+            <a:endParaRPr lang="en-US"/>
+          </a:p>
+        </p:txBody>
       </p:sp>
       <p:sp>
         <p:nvSpPr>
@@ -7714,7 +7727,7 @@
           <a:bodyPr wrap="square" rtlCol="0" anchor="ctr"/>
           <a:lstStyle/>
           <a:p>
-            <a:pPr indent="0" marL="0">
+            <a:pPr marL="0" indent="0">
               <a:buNone/>
             </a:pPr>
             <a:r>
@@ -7753,7 +7766,7 @@
           <a:bodyPr wrap="square" lIns="0" tIns="0" rIns="0" bIns="0" rtlCol="0" anchor="ctr"/>
           <a:lstStyle/>
           <a:p>
-            <a:pPr indent="0" marL="0">
+            <a:pPr marL="0" indent="0">
               <a:buNone/>
             </a:pPr>
             <a:r>
@@ -7795,6 +7808,13 @@
             <a:prstDash val="solid"/>
           </a:ln>
         </p:spPr>
+        <p:txBody>
+          <a:bodyPr/>
+          <a:lstStyle/>
+          <a:p>
+            <a:endParaRPr lang="en-US"/>
+          </a:p>
+        </p:txBody>
       </p:sp>
       <p:sp>
         <p:nvSpPr>
@@ -7817,7 +7837,7 @@
           <a:bodyPr wrap="square" lIns="0" tIns="0" rIns="0" bIns="0" rtlCol="0" anchor="ctr"/>
           <a:lstStyle/>
           <a:p>
-            <a:pPr algn="ctr" indent="0" marL="0">
+            <a:pPr marL="0" indent="0" algn="ctr">
               <a:buNone/>
             </a:pPr>
             <a:r>
@@ -7861,7 +7881,7 @@
           </a:bodyPr>
           <a:lstStyle/>
           <a:p>
-            <a:pPr algn="l" indent="0" marL="0">
+            <a:pPr marL="0" indent="0" algn="l">
               <a:buNone/>
             </a:pPr>
             <a:r>
@@ -7905,7 +7925,7 @@
           </a:bodyPr>
           <a:lstStyle/>
           <a:p>
-            <a:pPr algn="l" indent="0" marL="0">
+            <a:pPr marL="0" indent="0" algn="l">
               <a:buNone/>
             </a:pPr>
             <a:r>
@@ -7949,7 +7969,7 @@
           </a:bodyPr>
           <a:lstStyle/>
           <a:p>
-            <a:pPr algn="l" indent="0" marL="0">
+            <a:pPr marL="0" indent="0" algn="l">
               <a:buNone/>
             </a:pPr>
             <a:r>
@@ -7993,7 +8013,7 @@
           </a:bodyPr>
           <a:lstStyle/>
           <a:p>
-            <a:pPr algn="l" indent="0" marL="0">
+            <a:pPr marL="0" indent="0" algn="l">
               <a:buNone/>
             </a:pPr>
             <a:r>
@@ -8037,7 +8057,7 @@
           </a:bodyPr>
           <a:lstStyle/>
           <a:p>
-            <a:pPr algn="l" indent="0" marL="0">
+            <a:pPr marL="0" indent="0" algn="l">
               <a:buNone/>
             </a:pPr>
             <a:r>
@@ -8076,6 +8096,13 @@
             <a:prstDash val="solid"/>
           </a:ln>
         </p:spPr>
+        <p:txBody>
+          <a:bodyPr/>
+          <a:lstStyle/>
+          <a:p>
+            <a:endParaRPr lang="en-US"/>
+          </a:p>
+        </p:txBody>
       </p:sp>
       <p:sp>
         <p:nvSpPr>
@@ -8098,7 +8125,7 @@
           <a:bodyPr wrap="square" lIns="0" tIns="0" rIns="0" bIns="0" rtlCol="0" anchor="ctr"/>
           <a:lstStyle/>
           <a:p>
-            <a:pPr algn="ctr" indent="0" marL="0">
+            <a:pPr marL="0" indent="0" algn="ctr">
               <a:buNone/>
             </a:pPr>
             <a:r>
@@ -8142,7 +8169,7 @@
           </a:bodyPr>
           <a:lstStyle/>
           <a:p>
-            <a:pPr algn="l" indent="0" marL="0">
+            <a:pPr marL="0" indent="0" algn="l">
               <a:buNone/>
             </a:pPr>
             <a:r>
@@ -8186,7 +8213,7 @@
           </a:bodyPr>
           <a:lstStyle/>
           <a:p>
-            <a:pPr algn="l" indent="0" marL="0">
+            <a:pPr marL="0" indent="0" algn="l">
               <a:buNone/>
             </a:pPr>
             <a:r>
@@ -8230,7 +8257,7 @@
           </a:bodyPr>
           <a:lstStyle/>
           <a:p>
-            <a:pPr algn="l" indent="0" marL="0">
+            <a:pPr marL="0" indent="0" algn="l">
               <a:buNone/>
             </a:pPr>
             <a:r>
@@ -8274,7 +8301,7 @@
           </a:bodyPr>
           <a:lstStyle/>
           <a:p>
-            <a:pPr algn="l" indent="0" marL="0">
+            <a:pPr marL="0" indent="0" algn="l">
               <a:buNone/>
             </a:pPr>
             <a:r>
@@ -8318,7 +8345,7 @@
           </a:bodyPr>
           <a:lstStyle/>
           <a:p>
-            <a:pPr algn="l" indent="0" marL="0">
+            <a:pPr marL="0" indent="0" algn="l">
               <a:buNone/>
             </a:pPr>
             <a:r>
@@ -8357,6 +8384,13 @@
             <a:tailEnd type="triangle"/>
           </a:ln>
         </p:spPr>
+        <p:txBody>
+          <a:bodyPr/>
+          <a:lstStyle/>
+          <a:p>
+            <a:endParaRPr lang="en-US"/>
+          </a:p>
+        </p:txBody>
       </p:sp>
       <p:sp>
         <p:nvSpPr>
@@ -8379,7 +8413,7 @@
           <a:bodyPr wrap="square" lIns="0" tIns="0" rIns="0" bIns="0" rtlCol="0" anchor="ctr"/>
           <a:lstStyle/>
           <a:p>
-            <a:pPr algn="ctr" indent="0" marL="0">
+            <a:pPr marL="0" indent="0" algn="ctr">
               <a:buNone/>
             </a:pPr>
             <a:r>
@@ -8415,7 +8449,7 @@
           <a:bodyPr wrap="square" lIns="0" tIns="0" rIns="0" bIns="0" rtlCol="0" anchor="ctr"/>
           <a:lstStyle/>
           <a:p>
-            <a:pPr indent="0" marL="0">
+            <a:pPr marL="0" indent="0">
               <a:buNone/>
             </a:pPr>
             <a:r>
@@ -8451,7 +8485,7 @@
           <a:bodyPr wrap="square" lIns="0" tIns="0" rIns="0" bIns="0" rtlCol="0" anchor="ctr"/>
           <a:lstStyle/>
           <a:p>
-            <a:pPr algn="r" indent="0" marL="0">
+            <a:pPr marL="0" indent="0" algn="r">
               <a:buNone/>
             </a:pPr>
             <a:r>
@@ -8482,6 +8516,7 @@
         <a:solidFill>
           <a:srgbClr val="F8FAFC"/>
         </a:solidFill>
+        <a:effectLst/>
       </p:bgPr>
     </p:bg>
     <p:spTree>
@@ -8522,6 +8557,13 @@
             <a:prstDash val="solid"/>
           </a:ln>
         </p:spPr>
+        <p:txBody>
+          <a:bodyPr/>
+          <a:lstStyle/>
+          <a:p>
+            <a:endParaRPr lang="en-US"/>
+          </a:p>
+        </p:txBody>
       </p:sp>
       <p:sp>
         <p:nvSpPr>
@@ -8544,7 +8586,7 @@
           <a:bodyPr wrap="square" rtlCol="0" anchor="ctr"/>
           <a:lstStyle/>
           <a:p>
-            <a:pPr indent="0" marL="0">
+            <a:pPr marL="0" indent="0">
               <a:buNone/>
             </a:pPr>
             <a:r>
@@ -8583,7 +8625,7 @@
           <a:bodyPr wrap="square" lIns="0" tIns="0" rIns="0" bIns="0" rtlCol="0" anchor="ctr"/>
           <a:lstStyle/>
           <a:p>
-            <a:pPr indent="0" marL="0">
+            <a:pPr marL="0" indent="0">
               <a:buNone/>
             </a:pPr>
             <a:r>
@@ -8627,6 +8669,13 @@
             <a:prstDash val="solid"/>
           </a:ln>
         </p:spPr>
+        <p:txBody>
+          <a:bodyPr/>
+          <a:lstStyle/>
+          <a:p>
+            <a:endParaRPr lang="en-US"/>
+          </a:p>
+        </p:txBody>
       </p:sp>
       <p:sp>
         <p:nvSpPr>
@@ -8649,7 +8698,7 @@
           <a:bodyPr wrap="square" lIns="0" tIns="0" rIns="0" bIns="0" rtlCol="0" anchor="ctr"/>
           <a:lstStyle/>
           <a:p>
-            <a:pPr indent="0" marL="0">
+            <a:pPr marL="0" indent="0">
               <a:buNone/>
             </a:pPr>
             <a:r>
@@ -8693,7 +8742,7 @@
           </a:bodyPr>
           <a:lstStyle/>
           <a:p>
-            <a:pPr algn="l" indent="0" marL="0">
+            <a:pPr marL="0" indent="0" algn="l">
               <a:buNone/>
             </a:pPr>
             <a:r>
@@ -8707,7 +8756,7 @@
             <a:endParaRPr lang="en-US" sz="1050" dirty="0"/>
           </a:p>
           <a:p>
-            <a:pPr algn="l" indent="0" marL="0">
+            <a:pPr marL="0" indent="0" algn="l">
               <a:buNone/>
             </a:pPr>
             <a:r>
@@ -8721,7 +8770,7 @@
             <a:endParaRPr lang="en-US" sz="1050" dirty="0"/>
           </a:p>
           <a:p>
-            <a:pPr algn="l" indent="0" marL="0">
+            <a:pPr marL="0" indent="0" algn="l">
               <a:buNone/>
             </a:pPr>
             <a:r>
@@ -8735,7 +8784,7 @@
             <a:endParaRPr lang="en-US" sz="1050" dirty="0"/>
           </a:p>
           <a:p>
-            <a:pPr algn="l" indent="0" marL="0">
+            <a:pPr marL="0" indent="0" algn="l">
               <a:buNone/>
             </a:pPr>
             <a:r>
@@ -8779,7 +8828,7 @@
           </a:bodyPr>
           <a:lstStyle/>
           <a:p>
-            <a:pPr algn="l" indent="0" marL="0">
+            <a:pPr marL="0" indent="0" algn="l">
               <a:buNone/>
             </a:pPr>
             <a:r>
@@ -8793,7 +8842,7 @@
             <a:endParaRPr lang="en-US" sz="1050" dirty="0"/>
           </a:p>
           <a:p>
-            <a:pPr algn="l" indent="0" marL="0">
+            <a:pPr marL="0" indent="0" algn="l">
               <a:buNone/>
             </a:pPr>
             <a:r>
@@ -8807,7 +8856,7 @@
             <a:endParaRPr lang="en-US" sz="1050" dirty="0"/>
           </a:p>
           <a:p>
-            <a:pPr algn="l" indent="0" marL="0">
+            <a:pPr marL="0" indent="0" algn="l">
               <a:buNone/>
             </a:pPr>
             <a:r>
@@ -8821,7 +8870,7 @@
             <a:endParaRPr lang="en-US" sz="1050" dirty="0"/>
           </a:p>
           <a:p>
-            <a:pPr algn="l" indent="0" marL="0">
+            <a:pPr marL="0" indent="0" algn="l">
               <a:buNone/>
             </a:pPr>
             <a:r>
@@ -8865,7 +8914,7 @@
           </a:bodyPr>
           <a:lstStyle/>
           <a:p>
-            <a:pPr algn="l" indent="0" marL="0">
+            <a:pPr marL="0" indent="0" algn="l">
               <a:buNone/>
             </a:pPr>
             <a:r>
@@ -8879,7 +8928,7 @@
             <a:endParaRPr lang="en-US" sz="1050" dirty="0"/>
           </a:p>
           <a:p>
-            <a:pPr algn="l" indent="0" marL="0">
+            <a:pPr marL="0" indent="0" algn="l">
               <a:buNone/>
             </a:pPr>
             <a:r>
@@ -8893,7 +8942,7 @@
             <a:endParaRPr lang="en-US" sz="1050" dirty="0"/>
           </a:p>
           <a:p>
-            <a:pPr algn="l" indent="0" marL="0">
+            <a:pPr marL="0" indent="0" algn="l">
               <a:buNone/>
             </a:pPr>
             <a:r>
@@ -8907,7 +8956,7 @@
             <a:endParaRPr lang="en-US" sz="1050" dirty="0"/>
           </a:p>
           <a:p>
-            <a:pPr algn="l" indent="0" marL="0">
+            <a:pPr marL="0" indent="0" algn="l">
               <a:buNone/>
             </a:pPr>
             <a:r>
@@ -8951,7 +9000,7 @@
           </a:bodyPr>
           <a:lstStyle/>
           <a:p>
-            <a:pPr algn="l" indent="0" marL="0">
+            <a:pPr marL="0" indent="0" algn="l">
               <a:buNone/>
             </a:pPr>
             <a:r>
@@ -8965,7 +9014,7 @@
             <a:endParaRPr lang="en-US" sz="1050" dirty="0"/>
           </a:p>
           <a:p>
-            <a:pPr algn="l" indent="0" marL="0">
+            <a:pPr marL="0" indent="0" algn="l">
               <a:buNone/>
             </a:pPr>
             <a:r>
@@ -8979,7 +9028,7 @@
             <a:endParaRPr lang="en-US" sz="1050" dirty="0"/>
           </a:p>
           <a:p>
-            <a:pPr algn="l" indent="0" marL="0">
+            <a:pPr marL="0" indent="0" algn="l">
               <a:buNone/>
             </a:pPr>
             <a:r>
@@ -8993,7 +9042,7 @@
             <a:endParaRPr lang="en-US" sz="1050" dirty="0"/>
           </a:p>
           <a:p>
-            <a:pPr algn="l" indent="0" marL="0">
+            <a:pPr marL="0" indent="0" algn="l">
               <a:buNone/>
             </a:pPr>
             <a:r>
@@ -9007,7 +9056,7 @@
             <a:endParaRPr lang="en-US" sz="1050" dirty="0"/>
           </a:p>
           <a:p>
-            <a:pPr algn="l" indent="0" marL="0">
+            <a:pPr marL="0" indent="0" algn="l">
               <a:buNone/>
             </a:pPr>
             <a:r>
@@ -9048,6 +9097,13 @@
             <a:prstDash val="solid"/>
           </a:ln>
         </p:spPr>
+        <p:txBody>
+          <a:bodyPr/>
+          <a:lstStyle/>
+          <a:p>
+            <a:endParaRPr lang="en-US"/>
+          </a:p>
+        </p:txBody>
       </p:sp>
       <p:sp>
         <p:nvSpPr>
@@ -9070,7 +9126,7 @@
           <a:bodyPr wrap="square" lIns="0" tIns="0" rIns="0" bIns="0" rtlCol="0" anchor="ctr"/>
           <a:lstStyle/>
           <a:p>
-            <a:pPr algn="ctr" indent="0" marL="0">
+            <a:pPr marL="0" indent="0" algn="ctr">
               <a:buNone/>
             </a:pPr>
             <a:r>
@@ -9106,7 +9162,7 @@
           <a:bodyPr wrap="square" lIns="0" tIns="0" rIns="0" bIns="0" rtlCol="0" anchor="ctr"/>
           <a:lstStyle/>
           <a:p>
-            <a:pPr algn="ctr" indent="0" marL="0">
+            <a:pPr marL="0" indent="0" algn="ctr">
               <a:buNone/>
             </a:pPr>
             <a:r>
@@ -9147,6 +9203,13 @@
             <a:prstDash val="solid"/>
           </a:ln>
         </p:spPr>
+        <p:txBody>
+          <a:bodyPr/>
+          <a:lstStyle/>
+          <a:p>
+            <a:endParaRPr lang="en-US"/>
+          </a:p>
+        </p:txBody>
       </p:sp>
       <p:sp>
         <p:nvSpPr>
@@ -9169,7 +9232,7 @@
           <a:bodyPr wrap="square" lIns="0" tIns="0" rIns="0" bIns="0" rtlCol="0" anchor="ctr"/>
           <a:lstStyle/>
           <a:p>
-            <a:pPr algn="ctr" indent="0" marL="0">
+            <a:pPr marL="0" indent="0" algn="ctr">
               <a:buNone/>
             </a:pPr>
             <a:r>
@@ -9205,7 +9268,7 @@
           <a:bodyPr wrap="square" lIns="0" tIns="0" rIns="0" bIns="0" rtlCol="0" anchor="ctr"/>
           <a:lstStyle/>
           <a:p>
-            <a:pPr algn="ctr" indent="0" marL="0">
+            <a:pPr marL="0" indent="0" algn="ctr">
               <a:buNone/>
             </a:pPr>
             <a:r>
@@ -9246,6 +9309,13 @@
             <a:prstDash val="solid"/>
           </a:ln>
         </p:spPr>
+        <p:txBody>
+          <a:bodyPr/>
+          <a:lstStyle/>
+          <a:p>
+            <a:endParaRPr lang="en-US"/>
+          </a:p>
+        </p:txBody>
       </p:sp>
       <p:sp>
         <p:nvSpPr>
@@ -9268,7 +9338,7 @@
           <a:bodyPr wrap="square" lIns="0" tIns="0" rIns="0" bIns="0" rtlCol="0" anchor="ctr"/>
           <a:lstStyle/>
           <a:p>
-            <a:pPr algn="ctr" indent="0" marL="0">
+            <a:pPr marL="0" indent="0" algn="ctr">
               <a:buNone/>
             </a:pPr>
             <a:r>
@@ -9304,7 +9374,7 @@
           <a:bodyPr wrap="square" lIns="0" tIns="0" rIns="0" bIns="0" rtlCol="0" anchor="ctr"/>
           <a:lstStyle/>
           <a:p>
-            <a:pPr algn="ctr" indent="0" marL="0">
+            <a:pPr marL="0" indent="0" algn="ctr">
               <a:buNone/>
             </a:pPr>
             <a:r>
@@ -9345,6 +9415,13 @@
             <a:prstDash val="solid"/>
           </a:ln>
         </p:spPr>
+        <p:txBody>
+          <a:bodyPr/>
+          <a:lstStyle/>
+          <a:p>
+            <a:endParaRPr lang="en-US"/>
+          </a:p>
+        </p:txBody>
       </p:sp>
       <p:sp>
         <p:nvSpPr>
@@ -9367,7 +9444,7 @@
           <a:bodyPr wrap="square" lIns="0" tIns="0" rIns="0" bIns="0" rtlCol="0" anchor="ctr"/>
           <a:lstStyle/>
           <a:p>
-            <a:pPr algn="ctr" indent="0" marL="0">
+            <a:pPr marL="0" indent="0" algn="ctr">
               <a:buNone/>
             </a:pPr>
             <a:r>
@@ -9403,7 +9480,7 @@
           <a:bodyPr wrap="square" lIns="0" tIns="0" rIns="0" bIns="0" rtlCol="0" anchor="ctr"/>
           <a:lstStyle/>
           <a:p>
-            <a:pPr algn="ctr" indent="0" marL="0">
+            <a:pPr marL="0" indent="0" algn="ctr">
               <a:buNone/>
             </a:pPr>
             <a:r>
@@ -9444,6 +9521,13 @@
             <a:prstDash val="solid"/>
           </a:ln>
         </p:spPr>
+        <p:txBody>
+          <a:bodyPr/>
+          <a:lstStyle/>
+          <a:p>
+            <a:endParaRPr lang="en-US"/>
+          </a:p>
+        </p:txBody>
       </p:sp>
       <p:sp>
         <p:nvSpPr>
@@ -9466,7 +9550,7 @@
           <a:bodyPr wrap="square" lIns="0" tIns="0" rIns="0" bIns="0" rtlCol="0" anchor="ctr"/>
           <a:lstStyle/>
           <a:p>
-            <a:pPr algn="ctr" indent="0" marL="0">
+            <a:pPr marL="0" indent="0" algn="ctr">
               <a:buNone/>
             </a:pPr>
             <a:r>
@@ -9502,7 +9586,7 @@
           <a:bodyPr wrap="square" lIns="0" tIns="0" rIns="0" bIns="0" rtlCol="0" anchor="ctr"/>
           <a:lstStyle/>
           <a:p>
-            <a:pPr algn="ctr" indent="0" marL="0">
+            <a:pPr marL="0" indent="0" algn="ctr">
               <a:buNone/>
             </a:pPr>
             <a:r>
@@ -9543,6 +9627,13 @@
             <a:prstDash val="solid"/>
           </a:ln>
         </p:spPr>
+        <p:txBody>
+          <a:bodyPr/>
+          <a:lstStyle/>
+          <a:p>
+            <a:endParaRPr lang="en-US"/>
+          </a:p>
+        </p:txBody>
       </p:sp>
       <p:sp>
         <p:nvSpPr>
@@ -9565,7 +9656,7 @@
           <a:bodyPr wrap="square" lIns="0" tIns="0" rIns="0" bIns="0" rtlCol="0" anchor="ctr"/>
           <a:lstStyle/>
           <a:p>
-            <a:pPr algn="ctr" indent="0" marL="0">
+            <a:pPr marL="0" indent="0" algn="ctr">
               <a:buNone/>
             </a:pPr>
             <a:r>
@@ -9601,7 +9692,7 @@
           <a:bodyPr wrap="square" lIns="0" tIns="0" rIns="0" bIns="0" rtlCol="0" anchor="ctr"/>
           <a:lstStyle/>
           <a:p>
-            <a:pPr algn="ctr" indent="0" marL="0">
+            <a:pPr marL="0" indent="0" algn="ctr">
               <a:buNone/>
             </a:pPr>
             <a:r>
@@ -9637,7 +9728,7 @@
           <a:bodyPr wrap="square" lIns="0" tIns="0" rIns="0" bIns="0" rtlCol="0" anchor="ctr"/>
           <a:lstStyle/>
           <a:p>
-            <a:pPr algn="ctr" indent="0" marL="0">
+            <a:pPr marL="0" indent="0" algn="ctr">
               <a:buNone/>
             </a:pPr>
             <a:r>
@@ -9673,7 +9764,7 @@
           <a:bodyPr wrap="square" lIns="0" tIns="0" rIns="0" bIns="0" rtlCol="0" anchor="ctr"/>
           <a:lstStyle/>
           <a:p>
-            <a:pPr indent="0" marL="0">
+            <a:pPr marL="0" indent="0">
               <a:buNone/>
             </a:pPr>
             <a:r>
@@ -9709,7 +9800,7 @@
           <a:bodyPr wrap="square" lIns="0" tIns="0" rIns="0" bIns="0" rtlCol="0" anchor="ctr"/>
           <a:lstStyle/>
           <a:p>
-            <a:pPr algn="r" indent="0" marL="0">
+            <a:pPr marL="0" indent="0" algn="r">
               <a:buNone/>
             </a:pPr>
             <a:r>
@@ -9740,6 +9831,7 @@
         <a:solidFill>
           <a:srgbClr val="F8FAFC"/>
         </a:solidFill>
+        <a:effectLst/>
       </p:bgPr>
     </p:bg>
     <p:spTree>
@@ -9780,6 +9872,13 @@
             <a:prstDash val="solid"/>
           </a:ln>
         </p:spPr>
+        <p:txBody>
+          <a:bodyPr/>
+          <a:lstStyle/>
+          <a:p>
+            <a:endParaRPr lang="en-US"/>
+          </a:p>
+        </p:txBody>
       </p:sp>
       <p:sp>
         <p:nvSpPr>
@@ -9802,7 +9901,7 @@
           <a:bodyPr wrap="square" rtlCol="0" anchor="ctr"/>
           <a:lstStyle/>
           <a:p>
-            <a:pPr indent="0" marL="0">
+            <a:pPr marL="0" indent="0">
               <a:buNone/>
             </a:pPr>
             <a:r>
@@ -9841,7 +9940,7 @@
           <a:bodyPr wrap="square" lIns="0" tIns="0" rIns="0" bIns="0" rtlCol="0" anchor="ctr"/>
           <a:lstStyle/>
           <a:p>
-            <a:pPr indent="0" marL="0">
+            <a:pPr marL="0" indent="0">
               <a:buNone/>
             </a:pPr>
             <a:r>
@@ -9888,7 +9987,7 @@
           </a:bodyPr>
           <a:lstStyle/>
           <a:p>
-            <a:pPr algn="l" indent="0" marL="0">
+            <a:pPr marL="0" indent="0" algn="l">
               <a:buNone/>
             </a:pPr>
             <a:r>
@@ -9902,7 +10001,7 @@
             <a:endParaRPr lang="en-US" sz="1020" dirty="0"/>
           </a:p>
           <a:p>
-            <a:pPr algn="l" indent="0" marL="0">
+            <a:pPr marL="0" indent="0" algn="l">
               <a:buNone/>
             </a:pPr>
             <a:r>
@@ -9916,7 +10015,7 @@
             <a:endParaRPr lang="en-US" sz="1020" dirty="0"/>
           </a:p>
           <a:p>
-            <a:pPr algn="l" indent="0" marL="0">
+            <a:pPr marL="0" indent="0" algn="l">
               <a:buNone/>
             </a:pPr>
             <a:r>
@@ -9955,6 +10054,13 @@
             <a:tailEnd type="triangle"/>
           </a:ln>
         </p:spPr>
+        <p:txBody>
+          <a:bodyPr/>
+          <a:lstStyle/>
+          <a:p>
+            <a:endParaRPr lang="en-US"/>
+          </a:p>
+        </p:txBody>
       </p:sp>
       <p:sp>
         <p:nvSpPr>
@@ -9985,7 +10091,7 @@
           </a:bodyPr>
           <a:lstStyle/>
           <a:p>
-            <a:pPr algn="l" indent="0" marL="0">
+            <a:pPr marL="0" indent="0" algn="l">
               <a:buNone/>
             </a:pPr>
             <a:r>
@@ -9999,7 +10105,7 @@
             <a:endParaRPr lang="en-US" sz="1020" dirty="0"/>
           </a:p>
           <a:p>
-            <a:pPr algn="l" indent="0" marL="0">
+            <a:pPr marL="0" indent="0" algn="l">
               <a:buNone/>
             </a:pPr>
             <a:r>
@@ -10013,7 +10119,7 @@
             <a:endParaRPr lang="en-US" sz="1020" dirty="0"/>
           </a:p>
           <a:p>
-            <a:pPr algn="l" indent="0" marL="0">
+            <a:pPr marL="0" indent="0" algn="l">
               <a:buNone/>
             </a:pPr>
             <a:r>
@@ -10052,6 +10158,13 @@
             <a:tailEnd type="triangle"/>
           </a:ln>
         </p:spPr>
+        <p:txBody>
+          <a:bodyPr/>
+          <a:lstStyle/>
+          <a:p>
+            <a:endParaRPr lang="en-US"/>
+          </a:p>
+        </p:txBody>
       </p:sp>
       <p:sp>
         <p:nvSpPr>
@@ -10082,7 +10195,7 @@
           </a:bodyPr>
           <a:lstStyle/>
           <a:p>
-            <a:pPr algn="l" indent="0" marL="0">
+            <a:pPr marL="0" indent="0" algn="l">
               <a:buNone/>
             </a:pPr>
             <a:r>
@@ -10096,7 +10209,7 @@
             <a:endParaRPr lang="en-US" sz="1020" dirty="0"/>
           </a:p>
           <a:p>
-            <a:pPr algn="l" indent="0" marL="0">
+            <a:pPr marL="0" indent="0" algn="l">
               <a:buNone/>
             </a:pPr>
             <a:r>
@@ -10110,7 +10223,7 @@
             <a:endParaRPr lang="en-US" sz="1020" dirty="0"/>
           </a:p>
           <a:p>
-            <a:pPr algn="l" indent="0" marL="0">
+            <a:pPr marL="0" indent="0" algn="l">
               <a:buNone/>
             </a:pPr>
             <a:r>
@@ -10149,6 +10262,13 @@
             <a:tailEnd type="triangle"/>
           </a:ln>
         </p:spPr>
+        <p:txBody>
+          <a:bodyPr/>
+          <a:lstStyle/>
+          <a:p>
+            <a:endParaRPr lang="en-US"/>
+          </a:p>
+        </p:txBody>
       </p:sp>
       <p:sp>
         <p:nvSpPr>
@@ -10179,7 +10299,7 @@
           </a:bodyPr>
           <a:lstStyle/>
           <a:p>
-            <a:pPr algn="l" indent="0" marL="0">
+            <a:pPr marL="0" indent="0" algn="l">
               <a:buNone/>
             </a:pPr>
             <a:r>
@@ -10193,7 +10313,7 @@
             <a:endParaRPr lang="en-US" sz="1020" dirty="0"/>
           </a:p>
           <a:p>
-            <a:pPr algn="l" indent="0" marL="0">
+            <a:pPr marL="0" indent="0" algn="l">
               <a:buNone/>
             </a:pPr>
             <a:r>
@@ -10207,7 +10327,7 @@
             <a:endParaRPr lang="en-US" sz="1020" dirty="0"/>
           </a:p>
           <a:p>
-            <a:pPr algn="l" indent="0" marL="0">
+            <a:pPr marL="0" indent="0" algn="l">
               <a:buNone/>
             </a:pPr>
             <a:r>
@@ -10246,6 +10366,13 @@
             <a:tailEnd type="triangle"/>
           </a:ln>
         </p:spPr>
+        <p:txBody>
+          <a:bodyPr/>
+          <a:lstStyle/>
+          <a:p>
+            <a:endParaRPr lang="en-US"/>
+          </a:p>
+        </p:txBody>
       </p:sp>
       <p:sp>
         <p:nvSpPr>
@@ -10276,7 +10403,7 @@
           </a:bodyPr>
           <a:lstStyle/>
           <a:p>
-            <a:pPr algn="l" indent="0" marL="0">
+            <a:pPr marL="0" indent="0" algn="l">
               <a:buNone/>
             </a:pPr>
             <a:r>
@@ -10290,7 +10417,7 @@
             <a:endParaRPr lang="en-US" sz="1020" dirty="0"/>
           </a:p>
           <a:p>
-            <a:pPr algn="l" indent="0" marL="0">
+            <a:pPr marL="0" indent="0" algn="l">
               <a:buNone/>
             </a:pPr>
             <a:r>
@@ -10304,7 +10431,7 @@
             <a:endParaRPr lang="en-US" sz="1020" dirty="0"/>
           </a:p>
           <a:p>
-            <a:pPr algn="l" indent="0" marL="0">
+            <a:pPr marL="0" indent="0" algn="l">
               <a:buNone/>
             </a:pPr>
             <a:r>
@@ -10343,6 +10470,13 @@
             <a:tailEnd type="triangle"/>
           </a:ln>
         </p:spPr>
+        <p:txBody>
+          <a:bodyPr/>
+          <a:lstStyle/>
+          <a:p>
+            <a:endParaRPr lang="en-US"/>
+          </a:p>
+        </p:txBody>
       </p:sp>
       <p:sp>
         <p:nvSpPr>
@@ -10373,7 +10507,7 @@
           </a:bodyPr>
           <a:lstStyle/>
           <a:p>
-            <a:pPr algn="l" indent="0" marL="0">
+            <a:pPr marL="0" indent="0" algn="l">
               <a:buNone/>
             </a:pPr>
             <a:r>
@@ -10387,7 +10521,7 @@
             <a:endParaRPr lang="en-US" sz="1020" dirty="0"/>
           </a:p>
           <a:p>
-            <a:pPr algn="l" indent="0" marL="0">
+            <a:pPr marL="0" indent="0" algn="l">
               <a:buNone/>
             </a:pPr>
             <a:r>
@@ -10401,7 +10535,7 @@
             <a:endParaRPr lang="en-US" sz="1020" dirty="0"/>
           </a:p>
           <a:p>
-            <a:pPr algn="l" indent="0" marL="0">
+            <a:pPr marL="0" indent="0" algn="l">
               <a:buNone/>
             </a:pPr>
             <a:r>
@@ -10443,7 +10577,7 @@
           <a:bodyPr wrap="square" lIns="1016" tIns="1016" rIns="1016" bIns="1016" rtlCol="0" anchor="ctr"/>
           <a:lstStyle/>
           <a:p>
-            <a:pPr algn="ctr" indent="0" marL="0">
+            <a:pPr marL="0" indent="0" algn="ctr">
               <a:buNone/>
             </a:pPr>
             <a:r>
@@ -10479,7 +10613,7 @@
           <a:bodyPr wrap="square" lIns="0" tIns="0" rIns="0" bIns="0" rtlCol="0" anchor="ctr"/>
           <a:lstStyle/>
           <a:p>
-            <a:pPr algn="ctr" indent="0" marL="0">
+            <a:pPr marL="0" indent="0" algn="ctr">
               <a:buNone/>
             </a:pPr>
             <a:r>
@@ -10515,7 +10649,7 @@
           <a:bodyPr wrap="square" lIns="0" tIns="0" rIns="0" bIns="0" rtlCol="0" anchor="ctr"/>
           <a:lstStyle/>
           <a:p>
-            <a:pPr indent="0" marL="0">
+            <a:pPr marL="0" indent="0">
               <a:buNone/>
             </a:pPr>
             <a:r>
@@ -10551,7 +10685,7 @@
           <a:bodyPr wrap="square" lIns="0" tIns="0" rIns="0" bIns="0" rtlCol="0" anchor="ctr"/>
           <a:lstStyle/>
           <a:p>
-            <a:pPr algn="r" indent="0" marL="0">
+            <a:pPr marL="0" indent="0" algn="r">
               <a:buNone/>
             </a:pPr>
             <a:r>
@@ -10582,6 +10716,7 @@
         <a:solidFill>
           <a:srgbClr val="F8FAFC"/>
         </a:solidFill>
+        <a:effectLst/>
       </p:bgPr>
     </p:bg>
     <p:spTree>
@@ -10622,6 +10757,13 @@
             <a:prstDash val="solid"/>
           </a:ln>
         </p:spPr>
+        <p:txBody>
+          <a:bodyPr/>
+          <a:lstStyle/>
+          <a:p>
+            <a:endParaRPr lang="en-US"/>
+          </a:p>
+        </p:txBody>
       </p:sp>
       <p:sp>
         <p:nvSpPr>
@@ -10644,7 +10786,7 @@
           <a:bodyPr wrap="square" rtlCol="0" anchor="ctr"/>
           <a:lstStyle/>
           <a:p>
-            <a:pPr indent="0" marL="0">
+            <a:pPr marL="0" indent="0">
               <a:buNone/>
             </a:pPr>
             <a:r>
@@ -10683,7 +10825,7 @@
           <a:bodyPr wrap="square" lIns="0" tIns="0" rIns="0" bIns="0" rtlCol="0" anchor="ctr"/>
           <a:lstStyle/>
           <a:p>
-            <a:pPr indent="0" marL="0">
+            <a:pPr marL="0" indent="0">
               <a:buNone/>
             </a:pPr>
             <a:r>
@@ -10730,7 +10872,7 @@
           </a:bodyPr>
           <a:lstStyle/>
           <a:p>
-            <a:pPr algn="l" indent="0" marL="0">
+            <a:pPr marL="0" indent="0" algn="l">
               <a:buNone/>
             </a:pPr>
             <a:r>
@@ -10774,7 +10916,7 @@
           </a:bodyPr>
           <a:lstStyle/>
           <a:p>
-            <a:pPr algn="l" indent="0" marL="0">
+            <a:pPr marL="0" indent="0" algn="l">
               <a:buNone/>
             </a:pPr>
             <a:r>
@@ -10818,7 +10960,7 @@
           </a:bodyPr>
           <a:lstStyle/>
           <a:p>
-            <a:pPr algn="l" indent="0" marL="0">
+            <a:pPr marL="0" indent="0" algn="l">
               <a:buNone/>
             </a:pPr>
             <a:r>
@@ -10862,7 +11004,7 @@
           </a:bodyPr>
           <a:lstStyle/>
           <a:p>
-            <a:pPr algn="l" indent="0" marL="0">
+            <a:pPr marL="0" indent="0" algn="l">
               <a:buNone/>
             </a:pPr>
             <a:r>
@@ -10906,7 +11048,7 @@
           </a:bodyPr>
           <a:lstStyle/>
           <a:p>
-            <a:pPr algn="l" indent="0" marL="0">
+            <a:pPr marL="0" indent="0" algn="l">
               <a:buNone/>
             </a:pPr>
             <a:r>
@@ -10950,7 +11092,7 @@
           </a:bodyPr>
           <a:lstStyle/>
           <a:p>
-            <a:pPr algn="l" indent="0" marL="0">
+            <a:pPr marL="0" indent="0" algn="l">
               <a:buNone/>
             </a:pPr>
             <a:r>
@@ -10994,7 +11136,7 @@
           </a:bodyPr>
           <a:lstStyle/>
           <a:p>
-            <a:pPr algn="l" indent="0" marL="0">
+            <a:pPr marL="0" indent="0" algn="l">
               <a:buNone/>
             </a:pPr>
             <a:r>
@@ -11038,7 +11180,7 @@
           </a:bodyPr>
           <a:lstStyle/>
           <a:p>
-            <a:pPr algn="l" indent="0" marL="0">
+            <a:pPr marL="0" indent="0" algn="l">
               <a:buNone/>
             </a:pPr>
             <a:r>
@@ -11082,7 +11224,7 @@
           </a:bodyPr>
           <a:lstStyle/>
           <a:p>
-            <a:pPr algn="l" indent="0" marL="0">
+            <a:pPr marL="0" indent="0" algn="l">
               <a:buNone/>
             </a:pPr>
             <a:r>
@@ -11126,7 +11268,7 @@
           </a:bodyPr>
           <a:lstStyle/>
           <a:p>
-            <a:pPr algn="l" indent="0" marL="0">
+            <a:pPr marL="0" indent="0" algn="l">
               <a:buNone/>
             </a:pPr>
             <a:r>
@@ -11170,7 +11312,7 @@
           </a:bodyPr>
           <a:lstStyle/>
           <a:p>
-            <a:pPr algn="l" indent="0" marL="0">
+            <a:pPr marL="0" indent="0" algn="l">
               <a:buNone/>
             </a:pPr>
             <a:r>
@@ -11214,7 +11356,7 @@
           </a:bodyPr>
           <a:lstStyle/>
           <a:p>
-            <a:pPr algn="l" indent="0" marL="0">
+            <a:pPr marL="0" indent="0" algn="l">
               <a:buNone/>
             </a:pPr>
             <a:r>
@@ -11258,7 +11400,7 @@
           </a:bodyPr>
           <a:lstStyle/>
           <a:p>
-            <a:pPr algn="l" indent="0" marL="0">
+            <a:pPr marL="0" indent="0" algn="l">
               <a:buNone/>
             </a:pPr>
             <a:r>
@@ -11302,7 +11444,7 @@
           </a:bodyPr>
           <a:lstStyle/>
           <a:p>
-            <a:pPr algn="l" indent="0" marL="0">
+            <a:pPr marL="0" indent="0" algn="l">
               <a:buNone/>
             </a:pPr>
             <a:r>
@@ -11346,7 +11488,7 @@
           </a:bodyPr>
           <a:lstStyle/>
           <a:p>
-            <a:pPr algn="l" indent="0" marL="0">
+            <a:pPr marL="0" indent="0" algn="l">
               <a:buNone/>
             </a:pPr>
             <a:r>
@@ -11390,7 +11532,7 @@
           </a:bodyPr>
           <a:lstStyle/>
           <a:p>
-            <a:pPr algn="l" indent="0" marL="0">
+            <a:pPr marL="0" indent="0" algn="l">
               <a:buNone/>
             </a:pPr>
             <a:r>
@@ -11426,7 +11568,7 @@
           <a:bodyPr wrap="square" lIns="0" tIns="0" rIns="0" bIns="0" rtlCol="0" anchor="ctr"/>
           <a:lstStyle/>
           <a:p>
-            <a:pPr algn="ctr" indent="0" marL="0">
+            <a:pPr marL="0" indent="0" algn="ctr">
               <a:buNone/>
             </a:pPr>
             <a:r>
@@ -11462,7 +11604,7 @@
           <a:bodyPr wrap="square" lIns="0" tIns="0" rIns="0" bIns="0" rtlCol="0" anchor="ctr"/>
           <a:lstStyle/>
           <a:p>
-            <a:pPr indent="0" marL="0">
+            <a:pPr marL="0" indent="0">
               <a:buNone/>
             </a:pPr>
             <a:r>
@@ -11498,7 +11640,7 @@
           <a:bodyPr wrap="square" lIns="0" tIns="0" rIns="0" bIns="0" rtlCol="0" anchor="ctr"/>
           <a:lstStyle/>
           <a:p>
-            <a:pPr algn="r" indent="0" marL="0">
+            <a:pPr marL="0" indent="0" algn="r">
               <a:buNone/>
             </a:pPr>
             <a:r>
@@ -11529,6 +11671,7 @@
         <a:solidFill>
           <a:srgbClr val="F8FAFC"/>
         </a:solidFill>
+        <a:effectLst/>
       </p:bgPr>
     </p:bg>
     <p:spTree>
@@ -11569,6 +11712,13 @@
             <a:prstDash val="solid"/>
           </a:ln>
         </p:spPr>
+        <p:txBody>
+          <a:bodyPr/>
+          <a:lstStyle/>
+          <a:p>
+            <a:endParaRPr lang="en-US"/>
+          </a:p>
+        </p:txBody>
       </p:sp>
       <p:sp>
         <p:nvSpPr>
@@ -11591,7 +11741,7 @@
           <a:bodyPr wrap="square" rtlCol="0" anchor="ctr"/>
           <a:lstStyle/>
           <a:p>
-            <a:pPr indent="0" marL="0">
+            <a:pPr marL="0" indent="0">
               <a:buNone/>
             </a:pPr>
             <a:r>
@@ -11630,7 +11780,7 @@
           <a:bodyPr wrap="square" lIns="0" tIns="0" rIns="0" bIns="0" rtlCol="0" anchor="ctr"/>
           <a:lstStyle/>
           <a:p>
-            <a:pPr indent="0" marL="0">
+            <a:pPr marL="0" indent="0">
               <a:buNone/>
             </a:pPr>
             <a:r>
@@ -11672,6 +11822,13 @@
             <a:prstDash val="solid"/>
           </a:ln>
         </p:spPr>
+        <p:txBody>
+          <a:bodyPr/>
+          <a:lstStyle/>
+          <a:p>
+            <a:endParaRPr lang="en-US"/>
+          </a:p>
+        </p:txBody>
       </p:sp>
       <p:sp>
         <p:nvSpPr>
@@ -11694,7 +11851,7 @@
           <a:bodyPr wrap="square" lIns="0" tIns="0" rIns="0" bIns="0" rtlCol="0" anchor="ctr"/>
           <a:lstStyle/>
           <a:p>
-            <a:pPr algn="ctr" indent="0" marL="0">
+            <a:pPr marL="0" indent="0" algn="ctr">
               <a:buNone/>
             </a:pPr>
             <a:r>
@@ -11730,7 +11887,7 @@
           <a:bodyPr wrap="square" lIns="0" tIns="0" rIns="0" bIns="0" rtlCol="0" anchor="ctr"/>
           <a:lstStyle/>
           <a:p>
-            <a:pPr algn="ctr" indent="0" marL="0">
+            <a:pPr marL="0" indent="0" algn="ctr">
               <a:buNone/>
             </a:pPr>
             <a:r>
@@ -11744,7 +11901,7 @@
             <a:endParaRPr lang="en-US" sz="900" dirty="0"/>
           </a:p>
           <a:p>
-            <a:pPr algn="ctr" indent="0" marL="0">
+            <a:pPr marL="0" indent="0" algn="ctr">
               <a:buNone/>
             </a:pPr>
             <a:r>
@@ -11783,6 +11940,13 @@
             <a:tailEnd type="triangle"/>
           </a:ln>
         </p:spPr>
+        <p:txBody>
+          <a:bodyPr/>
+          <a:lstStyle/>
+          <a:p>
+            <a:endParaRPr lang="en-US"/>
+          </a:p>
+        </p:txBody>
       </p:sp>
       <p:sp>
         <p:nvSpPr>
@@ -11808,6 +11972,13 @@
             <a:prstDash val="solid"/>
           </a:ln>
         </p:spPr>
+        <p:txBody>
+          <a:bodyPr/>
+          <a:lstStyle/>
+          <a:p>
+            <a:endParaRPr lang="en-US"/>
+          </a:p>
+        </p:txBody>
       </p:sp>
       <p:sp>
         <p:nvSpPr>
@@ -11830,7 +12001,7 @@
           <a:bodyPr wrap="square" lIns="0" tIns="0" rIns="0" bIns="0" rtlCol="0" anchor="ctr"/>
           <a:lstStyle/>
           <a:p>
-            <a:pPr algn="ctr" indent="0" marL="0">
+            <a:pPr marL="0" indent="0" algn="ctr">
               <a:buNone/>
             </a:pPr>
             <a:r>
@@ -11866,7 +12037,7 @@
           <a:bodyPr wrap="square" lIns="0" tIns="0" rIns="0" bIns="0" rtlCol="0" anchor="ctr"/>
           <a:lstStyle/>
           <a:p>
-            <a:pPr algn="ctr" indent="0" marL="0">
+            <a:pPr marL="0" indent="0" algn="ctr">
               <a:buNone/>
             </a:pPr>
             <a:r>
@@ -11880,7 +12051,7 @@
             <a:endParaRPr lang="en-US" sz="900" dirty="0"/>
           </a:p>
           <a:p>
-            <a:pPr algn="ctr" indent="0" marL="0">
+            <a:pPr marL="0" indent="0" algn="ctr">
               <a:buNone/>
             </a:pPr>
             <a:r>
@@ -11919,6 +12090,13 @@
             <a:tailEnd type="triangle"/>
           </a:ln>
         </p:spPr>
+        <p:txBody>
+          <a:bodyPr/>
+          <a:lstStyle/>
+          <a:p>
+            <a:endParaRPr lang="en-US"/>
+          </a:p>
+        </p:txBody>
       </p:sp>
       <p:sp>
         <p:nvSpPr>
@@ -11944,6 +12122,13 @@
             <a:prstDash val="solid"/>
           </a:ln>
         </p:spPr>
+        <p:txBody>
+          <a:bodyPr/>
+          <a:lstStyle/>
+          <a:p>
+            <a:endParaRPr lang="en-US"/>
+          </a:p>
+        </p:txBody>
       </p:sp>
       <p:sp>
         <p:nvSpPr>
@@ -11966,7 +12151,7 @@
           <a:bodyPr wrap="square" lIns="0" tIns="0" rIns="0" bIns="0" rtlCol="0" anchor="ctr"/>
           <a:lstStyle/>
           <a:p>
-            <a:pPr algn="ctr" indent="0" marL="0">
+            <a:pPr marL="0" indent="0" algn="ctr">
               <a:buNone/>
             </a:pPr>
             <a:r>
@@ -12002,7 +12187,7 @@
           <a:bodyPr wrap="square" lIns="0" tIns="0" rIns="0" bIns="0" rtlCol="0" anchor="ctr"/>
           <a:lstStyle/>
           <a:p>
-            <a:pPr algn="ctr" indent="0" marL="0">
+            <a:pPr marL="0" indent="0" algn="ctr">
               <a:buNone/>
             </a:pPr>
             <a:r>
@@ -12016,7 +12201,7 @@
             <a:endParaRPr lang="en-US" sz="900" dirty="0"/>
           </a:p>
           <a:p>
-            <a:pPr algn="ctr" indent="0" marL="0">
+            <a:pPr marL="0" indent="0" algn="ctr">
               <a:buNone/>
             </a:pPr>
             <a:r>
@@ -12055,6 +12240,13 @@
             <a:tailEnd type="triangle"/>
           </a:ln>
         </p:spPr>
+        <p:txBody>
+          <a:bodyPr/>
+          <a:lstStyle/>
+          <a:p>
+            <a:endParaRPr lang="en-US"/>
+          </a:p>
+        </p:txBody>
       </p:sp>
       <p:sp>
         <p:nvSpPr>
@@ -12080,6 +12272,13 @@
             <a:prstDash val="solid"/>
           </a:ln>
         </p:spPr>
+        <p:txBody>
+          <a:bodyPr/>
+          <a:lstStyle/>
+          <a:p>
+            <a:endParaRPr lang="en-US"/>
+          </a:p>
+        </p:txBody>
       </p:sp>
       <p:sp>
         <p:nvSpPr>
@@ -12102,7 +12301,7 @@
           <a:bodyPr wrap="square" lIns="0" tIns="0" rIns="0" bIns="0" rtlCol="0" anchor="ctr"/>
           <a:lstStyle/>
           <a:p>
-            <a:pPr algn="ctr" indent="0" marL="0">
+            <a:pPr marL="0" indent="0" algn="ctr">
               <a:buNone/>
             </a:pPr>
             <a:r>
@@ -12138,7 +12337,7 @@
           <a:bodyPr wrap="square" lIns="0" tIns="0" rIns="0" bIns="0" rtlCol="0" anchor="ctr"/>
           <a:lstStyle/>
           <a:p>
-            <a:pPr algn="ctr" indent="0" marL="0">
+            <a:pPr marL="0" indent="0" algn="ctr">
               <a:buNone/>
             </a:pPr>
             <a:r>
@@ -12152,7 +12351,7 @@
             <a:endParaRPr lang="en-US" sz="900" dirty="0"/>
           </a:p>
           <a:p>
-            <a:pPr algn="ctr" indent="0" marL="0">
+            <a:pPr marL="0" indent="0" algn="ctr">
               <a:buNone/>
             </a:pPr>
             <a:r>
@@ -12191,6 +12390,13 @@
             <a:tailEnd type="triangle"/>
           </a:ln>
         </p:spPr>
+        <p:txBody>
+          <a:bodyPr/>
+          <a:lstStyle/>
+          <a:p>
+            <a:endParaRPr lang="en-US"/>
+          </a:p>
+        </p:txBody>
       </p:sp>
       <p:sp>
         <p:nvSpPr>
@@ -12216,6 +12422,13 @@
             <a:prstDash val="solid"/>
           </a:ln>
         </p:spPr>
+        <p:txBody>
+          <a:bodyPr/>
+          <a:lstStyle/>
+          <a:p>
+            <a:endParaRPr lang="en-US"/>
+          </a:p>
+        </p:txBody>
       </p:sp>
       <p:sp>
         <p:nvSpPr>
@@ -12238,7 +12451,7 @@
           <a:bodyPr wrap="square" lIns="0" tIns="0" rIns="0" bIns="0" rtlCol="0" anchor="ctr"/>
           <a:lstStyle/>
           <a:p>
-            <a:pPr algn="ctr" indent="0" marL="0">
+            <a:pPr marL="0" indent="0" algn="ctr">
               <a:buNone/>
             </a:pPr>
             <a:r>
@@ -12274,7 +12487,7 @@
           <a:bodyPr wrap="square" lIns="0" tIns="0" rIns="0" bIns="0" rtlCol="0" anchor="ctr"/>
           <a:lstStyle/>
           <a:p>
-            <a:pPr algn="ctr" indent="0" marL="0">
+            <a:pPr marL="0" indent="0" algn="ctr">
               <a:buNone/>
             </a:pPr>
             <a:r>
@@ -12288,7 +12501,7 @@
             <a:endParaRPr lang="en-US" sz="900" dirty="0"/>
           </a:p>
           <a:p>
-            <a:pPr algn="ctr" indent="0" marL="0">
+            <a:pPr marL="0" indent="0" algn="ctr">
               <a:buNone/>
             </a:pPr>
             <a:r>
@@ -12327,6 +12540,13 @@
             <a:tailEnd type="triangle"/>
           </a:ln>
         </p:spPr>
+        <p:txBody>
+          <a:bodyPr/>
+          <a:lstStyle/>
+          <a:p>
+            <a:endParaRPr lang="en-US"/>
+          </a:p>
+        </p:txBody>
       </p:sp>
       <p:sp>
         <p:nvSpPr>
@@ -12352,6 +12572,13 @@
             <a:prstDash val="solid"/>
           </a:ln>
         </p:spPr>
+        <p:txBody>
+          <a:bodyPr/>
+          <a:lstStyle/>
+          <a:p>
+            <a:endParaRPr lang="en-US"/>
+          </a:p>
+        </p:txBody>
       </p:sp>
       <p:sp>
         <p:nvSpPr>
@@ -12374,7 +12601,7 @@
           <a:bodyPr wrap="square" lIns="0" tIns="0" rIns="0" bIns="0" rtlCol="0" anchor="ctr"/>
           <a:lstStyle/>
           <a:p>
-            <a:pPr algn="ctr" indent="0" marL="0">
+            <a:pPr marL="0" indent="0" algn="ctr">
               <a:buNone/>
             </a:pPr>
             <a:r>
@@ -12410,7 +12637,7 @@
           <a:bodyPr wrap="square" lIns="0" tIns="0" rIns="0" bIns="0" rtlCol="0" anchor="ctr"/>
           <a:lstStyle/>
           <a:p>
-            <a:pPr algn="ctr" indent="0" marL="0">
+            <a:pPr marL="0" indent="0" algn="ctr">
               <a:buNone/>
             </a:pPr>
             <a:r>
@@ -12424,7 +12651,7 @@
             <a:endParaRPr lang="en-US" sz="900" dirty="0"/>
           </a:p>
           <a:p>
-            <a:pPr algn="ctr" indent="0" marL="0">
+            <a:pPr marL="0" indent="0" algn="ctr">
               <a:buNone/>
             </a:pPr>
             <a:r>
@@ -12460,7 +12687,7 @@
           <a:bodyPr wrap="square" lIns="0" tIns="0" rIns="0" bIns="0" rtlCol="0" anchor="ctr"/>
           <a:lstStyle/>
           <a:p>
-            <a:pPr indent="0" marL="0">
+            <a:pPr marL="0" indent="0">
               <a:buNone/>
             </a:pPr>
             <a:r>
@@ -12498,7 +12725,7 @@
           </a:bodyPr>
           <a:lstStyle/>
           <a:p>
-            <a:pPr indent="0" marL="0">
+            <a:pPr marL="0" indent="0">
               <a:buNone/>
             </a:pPr>
             <a:r>
@@ -12537,6 +12764,13 @@
             <a:prstDash val="solid"/>
           </a:ln>
         </p:spPr>
+        <p:txBody>
+          <a:bodyPr/>
+          <a:lstStyle/>
+          <a:p>
+            <a:endParaRPr lang="en-US"/>
+          </a:p>
+        </p:txBody>
       </p:sp>
       <p:sp>
         <p:nvSpPr>
@@ -12559,7 +12793,7 @@
           <a:bodyPr wrap="square" lIns="0" tIns="0" rIns="0" bIns="0" rtlCol="0" anchor="ctr"/>
           <a:lstStyle/>
           <a:p>
-            <a:pPr algn="ctr" indent="0" marL="0">
+            <a:pPr marL="0" indent="0" algn="ctr">
               <a:buNone/>
             </a:pPr>
             <a:r>
@@ -12595,7 +12829,7 @@
           <a:bodyPr wrap="square" lIns="0" tIns="0" rIns="0" bIns="0" rtlCol="0" anchor="ctr"/>
           <a:lstStyle/>
           <a:p>
-            <a:pPr indent="0" marL="0">
+            <a:pPr marL="0" indent="0">
               <a:buNone/>
             </a:pPr>
             <a:r>
@@ -12631,7 +12865,7 @@
           <a:bodyPr wrap="square" lIns="0" tIns="0" rIns="0" bIns="0" rtlCol="0" anchor="ctr"/>
           <a:lstStyle/>
           <a:p>
-            <a:pPr algn="r" indent="0" marL="0">
+            <a:pPr marL="0" indent="0" algn="r">
               <a:buNone/>
             </a:pPr>
             <a:r>
@@ -12662,6 +12896,7 @@
         <a:solidFill>
           <a:srgbClr val="F8FAFC"/>
         </a:solidFill>
+        <a:effectLst/>
       </p:bgPr>
     </p:bg>
     <p:spTree>
@@ -12702,6 +12937,13 @@
             <a:prstDash val="solid"/>
           </a:ln>
         </p:spPr>
+        <p:txBody>
+          <a:bodyPr/>
+          <a:lstStyle/>
+          <a:p>
+            <a:endParaRPr lang="en-US"/>
+          </a:p>
+        </p:txBody>
       </p:sp>
       <p:sp>
         <p:nvSpPr>
@@ -12724,7 +12966,7 @@
           <a:bodyPr wrap="square" rtlCol="0" anchor="ctr"/>
           <a:lstStyle/>
           <a:p>
-            <a:pPr indent="0" marL="0">
+            <a:pPr marL="0" indent="0">
               <a:buNone/>
             </a:pPr>
             <a:r>
@@ -12763,7 +13005,7 @@
           <a:bodyPr wrap="square" lIns="0" tIns="0" rIns="0" bIns="0" rtlCol="0" anchor="ctr"/>
           <a:lstStyle/>
           <a:p>
-            <a:pPr indent="0" marL="0">
+            <a:pPr marL="0" indent="0">
               <a:buNone/>
             </a:pPr>
             <a:r>
@@ -12802,7 +13044,7 @@
           <a:bodyPr wrap="square" lIns="0" tIns="0" rIns="0" bIns="0" rtlCol="0" anchor="ctr"/>
           <a:lstStyle/>
           <a:p>
-            <a:pPr indent="0" marL="0">
+            <a:pPr marL="0" indent="0">
               <a:buNone/>
             </a:pPr>
             <a:r>
@@ -12846,7 +13088,7 @@
           </a:bodyPr>
           <a:lstStyle/>
           <a:p>
-            <a:pPr algn="l" indent="0" marL="0">
+            <a:pPr marL="0" indent="0" algn="l">
               <a:buNone/>
             </a:pPr>
             <a:r>
@@ -12890,7 +13132,7 @@
           </a:bodyPr>
           <a:lstStyle/>
           <a:p>
-            <a:pPr algn="l" indent="0" marL="0">
+            <a:pPr marL="0" indent="0" algn="l">
               <a:buNone/>
             </a:pPr>
             <a:r>
@@ -12934,7 +13176,7 @@
           </a:bodyPr>
           <a:lstStyle/>
           <a:p>
-            <a:pPr algn="l" indent="0" marL="0">
+            <a:pPr marL="0" indent="0" algn="l">
               <a:buNone/>
             </a:pPr>
             <a:r>
@@ -12978,7 +13220,7 @@
           </a:bodyPr>
           <a:lstStyle/>
           <a:p>
-            <a:pPr algn="l" indent="0" marL="0">
+            <a:pPr marL="0" indent="0" algn="l">
               <a:buNone/>
             </a:pPr>
             <a:r>
@@ -13022,7 +13264,7 @@
           </a:bodyPr>
           <a:lstStyle/>
           <a:p>
-            <a:pPr algn="l" indent="0" marL="0">
+            <a:pPr marL="0" indent="0" algn="l">
               <a:buNone/>
             </a:pPr>
             <a:r>
@@ -13066,7 +13308,7 @@
           </a:bodyPr>
           <a:lstStyle/>
           <a:p>
-            <a:pPr algn="l" indent="0" marL="0">
+            <a:pPr marL="0" indent="0" algn="l">
               <a:buNone/>
             </a:pPr>
             <a:r>
@@ -13110,7 +13352,7 @@
           </a:bodyPr>
           <a:lstStyle/>
           <a:p>
-            <a:pPr algn="l" indent="0" marL="0">
+            <a:pPr marL="0" indent="0" algn="l">
               <a:buNone/>
             </a:pPr>
             <a:r>
@@ -13154,7 +13396,7 @@
           </a:bodyPr>
           <a:lstStyle/>
           <a:p>
-            <a:pPr algn="l" indent="0" marL="0">
+            <a:pPr marL="0" indent="0" algn="l">
               <a:buNone/>
             </a:pPr>
             <a:r>
@@ -13198,7 +13440,7 @@
           </a:bodyPr>
           <a:lstStyle/>
           <a:p>
-            <a:pPr algn="l" indent="0" marL="0">
+            <a:pPr marL="0" indent="0" algn="l">
               <a:buNone/>
             </a:pPr>
             <a:r>
@@ -13242,7 +13484,7 @@
           </a:bodyPr>
           <a:lstStyle/>
           <a:p>
-            <a:pPr algn="l" indent="0" marL="0">
+            <a:pPr marL="0" indent="0" algn="l">
               <a:buNone/>
             </a:pPr>
             <a:r>
@@ -13286,7 +13528,7 @@
           </a:bodyPr>
           <a:lstStyle/>
           <a:p>
-            <a:pPr algn="l" indent="0" marL="0">
+            <a:pPr marL="0" indent="0" algn="l">
               <a:buNone/>
             </a:pPr>
             <a:r>
@@ -13330,7 +13572,7 @@
           </a:bodyPr>
           <a:lstStyle/>
           <a:p>
-            <a:pPr algn="l" indent="0" marL="0">
+            <a:pPr marL="0" indent="0" algn="l">
               <a:buNone/>
             </a:pPr>
             <a:r>
@@ -13369,6 +13611,13 @@
             <a:prstDash val="solid"/>
           </a:ln>
         </p:spPr>
+        <p:txBody>
+          <a:bodyPr/>
+          <a:lstStyle/>
+          <a:p>
+            <a:endParaRPr lang="en-US"/>
+          </a:p>
+        </p:txBody>
       </p:sp>
       <p:sp>
         <p:nvSpPr>
@@ -13391,7 +13640,7 @@
           <a:bodyPr wrap="square" lIns="0" tIns="0" rIns="0" bIns="0" rtlCol="0" anchor="ctr"/>
           <a:lstStyle/>
           <a:p>
-            <a:pPr algn="ctr" indent="0" marL="0">
+            <a:pPr marL="0" indent="0" algn="ctr">
               <a:buNone/>
             </a:pPr>
             <a:r>
@@ -13427,7 +13676,7 @@
           <a:bodyPr wrap="square" lIns="0" tIns="0" rIns="0" bIns="0" rtlCol="0" anchor="ctr"/>
           <a:lstStyle/>
           <a:p>
-            <a:pPr algn="ctr" indent="0" marL="0">
+            <a:pPr marL="0" indent="0" algn="ctr">
               <a:buNone/>
             </a:pPr>
             <a:r>
@@ -13463,7 +13712,7 @@
           <a:bodyPr wrap="square" lIns="0" tIns="0" rIns="0" bIns="0" rtlCol="0" anchor="ctr"/>
           <a:lstStyle/>
           <a:p>
-            <a:pPr algn="ctr" indent="0" marL="0">
+            <a:pPr marL="0" indent="0" algn="ctr">
               <a:buNone/>
             </a:pPr>
             <a:r>
@@ -13499,7 +13748,7 @@
           <a:bodyPr wrap="square" lIns="0" tIns="0" rIns="0" bIns="0" rtlCol="0" anchor="ctr"/>
           <a:lstStyle/>
           <a:p>
-            <a:pPr indent="0" marL="0">
+            <a:pPr marL="0" indent="0">
               <a:buNone/>
             </a:pPr>
             <a:r>
@@ -13535,7 +13784,7 @@
           <a:bodyPr wrap="square" lIns="0" tIns="0" rIns="0" bIns="0" rtlCol="0" anchor="ctr"/>
           <a:lstStyle/>
           <a:p>
-            <a:pPr algn="r" indent="0" marL="0">
+            <a:pPr marL="0" indent="0" algn="r">
               <a:buNone/>
             </a:pPr>
             <a:r>
@@ -13566,6 +13815,7 @@
         <a:solidFill>
           <a:srgbClr val="F8FAFC"/>
         </a:solidFill>
+        <a:effectLst/>
       </p:bgPr>
     </p:bg>
     <p:spTree>
@@ -13606,6 +13856,13 @@
             <a:prstDash val="solid"/>
           </a:ln>
         </p:spPr>
+        <p:txBody>
+          <a:bodyPr/>
+          <a:lstStyle/>
+          <a:p>
+            <a:endParaRPr lang="en-US"/>
+          </a:p>
+        </p:txBody>
       </p:sp>
       <p:sp>
         <p:nvSpPr>
@@ -13628,7 +13885,7 @@
           <a:bodyPr wrap="square" rtlCol="0" anchor="ctr"/>
           <a:lstStyle/>
           <a:p>
-            <a:pPr indent="0" marL="0">
+            <a:pPr marL="0" indent="0">
               <a:buNone/>
             </a:pPr>
             <a:r>
@@ -13667,7 +13924,7 @@
           <a:bodyPr wrap="square" lIns="0" tIns="0" rIns="0" bIns="0" rtlCol="0" anchor="ctr"/>
           <a:lstStyle/>
           <a:p>
-            <a:pPr indent="0" marL="0">
+            <a:pPr marL="0" indent="0">
               <a:buNone/>
             </a:pPr>
             <a:r>
@@ -13711,6 +13968,13 @@
             <a:prstDash val="solid"/>
           </a:ln>
         </p:spPr>
+        <p:txBody>
+          <a:bodyPr/>
+          <a:lstStyle/>
+          <a:p>
+            <a:endParaRPr lang="en-US"/>
+          </a:p>
+        </p:txBody>
       </p:sp>
       <p:sp>
         <p:nvSpPr>
@@ -13733,7 +13997,7 @@
           <a:bodyPr wrap="square" lIns="0" tIns="0" rIns="0" bIns="0" rtlCol="0" anchor="ctr"/>
           <a:lstStyle/>
           <a:p>
-            <a:pPr indent="0" marL="0">
+            <a:pPr marL="0" indent="0">
               <a:buNone/>
             </a:pPr>
             <a:r>
@@ -13769,7 +14033,7 @@
           <a:bodyPr wrap="square" lIns="0" tIns="0" rIns="0" bIns="0" rtlCol="0" anchor="ctr"/>
           <a:lstStyle/>
           <a:p>
-            <a:pPr indent="0" marL="0">
+            <a:pPr marL="0" indent="0">
               <a:buNone/>
             </a:pPr>
             <a:r>
@@ -13810,6 +14074,13 @@
             <a:prstDash val="solid"/>
           </a:ln>
         </p:spPr>
+        <p:txBody>
+          <a:bodyPr/>
+          <a:lstStyle/>
+          <a:p>
+            <a:endParaRPr lang="en-US"/>
+          </a:p>
+        </p:txBody>
       </p:sp>
       <p:sp>
         <p:nvSpPr>
@@ -13832,7 +14103,7 @@
           <a:bodyPr wrap="square" lIns="0" tIns="0" rIns="0" bIns="0" rtlCol="0" anchor="ctr"/>
           <a:lstStyle/>
           <a:p>
-            <a:pPr indent="0" marL="0">
+            <a:pPr marL="0" indent="0">
               <a:buNone/>
             </a:pPr>
             <a:r>
@@ -13868,7 +14139,7 @@
           <a:bodyPr wrap="square" lIns="0" tIns="0" rIns="0" bIns="0" rtlCol="0" anchor="ctr"/>
           <a:lstStyle/>
           <a:p>
-            <a:pPr indent="0" marL="0">
+            <a:pPr marL="0" indent="0">
               <a:buNone/>
             </a:pPr>
             <a:r>
@@ -13909,6 +14180,13 @@
             <a:prstDash val="solid"/>
           </a:ln>
         </p:spPr>
+        <p:txBody>
+          <a:bodyPr/>
+          <a:lstStyle/>
+          <a:p>
+            <a:endParaRPr lang="en-US"/>
+          </a:p>
+        </p:txBody>
       </p:sp>
       <p:sp>
         <p:nvSpPr>
@@ -13931,7 +14209,7 @@
           <a:bodyPr wrap="square" lIns="0" tIns="0" rIns="0" bIns="0" rtlCol="0" anchor="ctr"/>
           <a:lstStyle/>
           <a:p>
-            <a:pPr indent="0" marL="0">
+            <a:pPr marL="0" indent="0">
               <a:buNone/>
             </a:pPr>
             <a:r>
@@ -13967,7 +14245,7 @@
           <a:bodyPr wrap="square" lIns="0" tIns="0" rIns="0" bIns="0" rtlCol="0" anchor="ctr"/>
           <a:lstStyle/>
           <a:p>
-            <a:pPr indent="0" marL="0">
+            <a:pPr marL="0" indent="0">
               <a:buNone/>
             </a:pPr>
             <a:r>
@@ -14008,6 +14286,13 @@
             <a:prstDash val="solid"/>
           </a:ln>
         </p:spPr>
+        <p:txBody>
+          <a:bodyPr/>
+          <a:lstStyle/>
+          <a:p>
+            <a:endParaRPr lang="en-US"/>
+          </a:p>
+        </p:txBody>
       </p:sp>
       <p:sp>
         <p:nvSpPr>
@@ -14030,7 +14315,7 @@
           <a:bodyPr wrap="square" lIns="0" tIns="0" rIns="0" bIns="0" rtlCol="0" anchor="ctr"/>
           <a:lstStyle/>
           <a:p>
-            <a:pPr indent="0" marL="0">
+            <a:pPr marL="0" indent="0">
               <a:buNone/>
             </a:pPr>
             <a:r>
@@ -14066,7 +14351,7 @@
           <a:bodyPr wrap="square" lIns="0" tIns="0" rIns="0" bIns="0" rtlCol="0" anchor="ctr"/>
           <a:lstStyle/>
           <a:p>
-            <a:pPr indent="0" marL="0">
+            <a:pPr marL="0" indent="0">
               <a:buNone/>
             </a:pPr>
             <a:r>
@@ -14107,6 +14392,13 @@
             <a:prstDash val="solid"/>
           </a:ln>
         </p:spPr>
+        <p:txBody>
+          <a:bodyPr/>
+          <a:lstStyle/>
+          <a:p>
+            <a:endParaRPr lang="en-US"/>
+          </a:p>
+        </p:txBody>
       </p:sp>
       <p:sp>
         <p:nvSpPr>
@@ -14129,7 +14421,7 @@
           <a:bodyPr wrap="square" lIns="0" tIns="0" rIns="0" bIns="0" rtlCol="0" anchor="ctr"/>
           <a:lstStyle/>
           <a:p>
-            <a:pPr indent="0" marL="0">
+            <a:pPr marL="0" indent="0">
               <a:buNone/>
             </a:pPr>
             <a:r>
@@ -14165,7 +14457,7 @@
           <a:bodyPr wrap="square" lIns="0" tIns="0" rIns="0" bIns="0" rtlCol="0" anchor="ctr"/>
           <a:lstStyle/>
           <a:p>
-            <a:pPr indent="0" marL="0">
+            <a:pPr marL="0" indent="0">
               <a:buNone/>
             </a:pPr>
             <a:r>
@@ -14206,6 +14498,13 @@
             <a:prstDash val="solid"/>
           </a:ln>
         </p:spPr>
+        <p:txBody>
+          <a:bodyPr/>
+          <a:lstStyle/>
+          <a:p>
+            <a:endParaRPr lang="en-US"/>
+          </a:p>
+        </p:txBody>
       </p:sp>
       <p:sp>
         <p:nvSpPr>
@@ -14228,7 +14527,7 @@
           <a:bodyPr wrap="square" lIns="0" tIns="0" rIns="0" bIns="0" rtlCol="0" anchor="ctr"/>
           <a:lstStyle/>
           <a:p>
-            <a:pPr indent="0" marL="0">
+            <a:pPr marL="0" indent="0">
               <a:buNone/>
             </a:pPr>
             <a:r>
@@ -14264,7 +14563,7 @@
           <a:bodyPr wrap="square" lIns="0" tIns="0" rIns="0" bIns="0" rtlCol="0" anchor="ctr"/>
           <a:lstStyle/>
           <a:p>
-            <a:pPr indent="0" marL="0">
+            <a:pPr marL="0" indent="0">
               <a:buNone/>
             </a:pPr>
             <a:r>
@@ -14306,7 +14605,7 @@
           <a:bodyPr wrap="square" lIns="0" tIns="0" rIns="0" bIns="0" rtlCol="0" anchor="ctr"/>
           <a:lstStyle/>
           <a:p>
-            <a:pPr algn="ctr" indent="0" marL="0">
+            <a:pPr marL="0" indent="0" algn="ctr">
               <a:buNone/>
             </a:pPr>
             <a:r>
@@ -14342,7 +14641,7 @@
           <a:bodyPr wrap="square" lIns="0" tIns="0" rIns="0" bIns="0" rtlCol="0" anchor="ctr"/>
           <a:lstStyle/>
           <a:p>
-            <a:pPr indent="0" marL="0">
+            <a:pPr marL="0" indent="0">
               <a:buNone/>
             </a:pPr>
             <a:r>
@@ -14378,7 +14677,7 @@
           <a:bodyPr wrap="square" lIns="0" tIns="0" rIns="0" bIns="0" rtlCol="0" anchor="ctr"/>
           <a:lstStyle/>
           <a:p>
-            <a:pPr algn="r" indent="0" marL="0">
+            <a:pPr marL="0" indent="0" algn="r">
               <a:buNone/>
             </a:pPr>
             <a:r>
@@ -14694,4 +14993,319 @@
     </a:ext>
   </a:extLst>
 </a:theme>
+</file>
+
+<file path=ppt/theme/theme2.xml><?xml version="1.0" encoding="utf-8"?>
+<a:theme xmlns:a="http://schemas.openxmlformats.org/drawingml/2006/main" name="Office Theme">
+  <a:themeElements>
+    <a:clrScheme name="Office">
+      <a:dk1>
+        <a:sysClr val="windowText" lastClr="000000"/>
+      </a:dk1>
+      <a:lt1>
+        <a:sysClr val="window" lastClr="FFFFFF"/>
+      </a:lt1>
+      <a:dk2>
+        <a:srgbClr val="0E2841"/>
+      </a:dk2>
+      <a:lt2>
+        <a:srgbClr val="E8E8E8"/>
+      </a:lt2>
+      <a:accent1>
+        <a:srgbClr val="156082"/>
+      </a:accent1>
+      <a:accent2>
+        <a:srgbClr val="E97132"/>
+      </a:accent2>
+      <a:accent3>
+        <a:srgbClr val="196B24"/>
+      </a:accent3>
+      <a:accent4>
+        <a:srgbClr val="0F9ED5"/>
+      </a:accent4>
+      <a:accent5>
+        <a:srgbClr val="A02B93"/>
+      </a:accent5>
+      <a:accent6>
+        <a:srgbClr val="4EA72E"/>
+      </a:accent6>
+      <a:hlink>
+        <a:srgbClr val="467886"/>
+      </a:hlink>
+      <a:folHlink>
+        <a:srgbClr val="96607D"/>
+      </a:folHlink>
+    </a:clrScheme>
+    <a:fontScheme name="Office">
+      <a:majorFont>
+        <a:latin typeface="Aptos Display" panose="02110004020202020204"/>
+        <a:ea typeface=""/>
+        <a:cs typeface=""/>
+        <a:font script="Jpan" typeface="游ゴシック Light"/>
+        <a:font script="Hang" typeface="맑은 고딕"/>
+        <a:font script="Hans" typeface="等线 Light"/>
+        <a:font script="Hant" typeface="新細明體"/>
+        <a:font script="Arab" typeface="Times New Roman"/>
+        <a:font script="Hebr" typeface="Times New Roman"/>
+        <a:font script="Thai" typeface="Angsana New"/>
+        <a:font script="Ethi" typeface="Nyala"/>
+        <a:font script="Beng" typeface="Vrinda"/>
+        <a:font script="Gujr" typeface="Shruti"/>
+        <a:font script="Khmr" typeface="MoolBoran"/>
+        <a:font script="Knda" typeface="Tunga"/>
+        <a:font script="Guru" typeface="Raavi"/>
+        <a:font script="Cans" typeface="Euphemia"/>
+        <a:font script="Cher" typeface="Plantagenet Cherokee"/>
+        <a:font script="Yiii" typeface="Microsoft Yi Baiti"/>
+        <a:font script="Tibt" typeface="Microsoft Himalaya"/>
+        <a:font script="Thaa" typeface="MV Boli"/>
+        <a:font script="Deva" typeface="Mangal"/>
+        <a:font script="Telu" typeface="Gautami"/>
+        <a:font script="Taml" typeface="Latha"/>
+        <a:font script="Syrc" typeface="Estrangelo Edessa"/>
+        <a:font script="Orya" typeface="Kalinga"/>
+        <a:font script="Mlym" typeface="Kartika"/>
+        <a:font script="Laoo" typeface="DokChampa"/>
+        <a:font script="Sinh" typeface="Iskoola Pota"/>
+        <a:font script="Mong" typeface="Mongolian Baiti"/>
+        <a:font script="Viet" typeface="Times New Roman"/>
+        <a:font script="Uigh" typeface="Microsoft Uighur"/>
+        <a:font script="Geor" typeface="Sylfaen"/>
+        <a:font script="Armn" typeface="Arial"/>
+        <a:font script="Bugi" typeface="Leelawadee UI"/>
+        <a:font script="Bopo" typeface="Microsoft JhengHei"/>
+        <a:font script="Java" typeface="Javanese Text"/>
+        <a:font script="Lisu" typeface="Segoe UI"/>
+        <a:font script="Mymr" typeface="Myanmar Text"/>
+        <a:font script="Nkoo" typeface="Ebrima"/>
+        <a:font script="Olck" typeface="Nirmala UI"/>
+        <a:font script="Osma" typeface="Ebrima"/>
+        <a:font script="Phag" typeface="Phagspa"/>
+        <a:font script="Syrn" typeface="Estrangelo Edessa"/>
+        <a:font script="Syrj" typeface="Estrangelo Edessa"/>
+        <a:font script="Syre" typeface="Estrangelo Edessa"/>
+        <a:font script="Sora" typeface="Nirmala UI"/>
+        <a:font script="Tale" typeface="Microsoft Tai Le"/>
+        <a:font script="Talu" typeface="Microsoft New Tai Lue"/>
+        <a:font script="Tfng" typeface="Ebrima"/>
+      </a:majorFont>
+      <a:minorFont>
+        <a:latin typeface="Aptos" panose="02110004020202020204"/>
+        <a:ea typeface=""/>
+        <a:cs typeface=""/>
+        <a:font script="Jpan" typeface="游ゴシック"/>
+        <a:font script="Hang" typeface="맑은 고딕"/>
+        <a:font script="Hans" typeface="等线"/>
+        <a:font script="Hant" typeface="新細明體"/>
+        <a:font script="Arab" typeface="Arial"/>
+        <a:font script="Hebr" typeface="Arial"/>
+        <a:font script="Thai" typeface="Cordia New"/>
+        <a:font script="Ethi" typeface="Nyala"/>
+        <a:font script="Beng" typeface="Vrinda"/>
+        <a:font script="Gujr" typeface="Shruti"/>
+        <a:font script="Khmr" typeface="DaunPenh"/>
+        <a:font script="Knda" typeface="Tunga"/>
+        <a:font script="Guru" typeface="Raavi"/>
+        <a:font script="Cans" typeface="Euphemia"/>
+        <a:font script="Cher" typeface="Plantagenet Cherokee"/>
+        <a:font script="Yiii" typeface="Microsoft Yi Baiti"/>
+        <a:font script="Tibt" typeface="Microsoft Himalaya"/>
+        <a:font script="Thaa" typeface="MV Boli"/>
+        <a:font script="Deva" typeface="Mangal"/>
+        <a:font script="Telu" typeface="Gautami"/>
+        <a:font script="Taml" typeface="Latha"/>
+        <a:font script="Syrc" typeface="Estrangelo Edessa"/>
+        <a:font script="Orya" typeface="Kalinga"/>
+        <a:font script="Mlym" typeface="Kartika"/>
+        <a:font script="Laoo" typeface="DokChampa"/>
+        <a:font script="Sinh" typeface="Iskoola Pota"/>
+        <a:font script="Mong" typeface="Mongolian Baiti"/>
+        <a:font script="Viet" typeface="Arial"/>
+        <a:font script="Uigh" typeface="Microsoft Uighur"/>
+        <a:font script="Geor" typeface="Sylfaen"/>
+        <a:font script="Armn" typeface="Arial"/>
+        <a:font script="Bugi" typeface="Leelawadee UI"/>
+        <a:font script="Bopo" typeface="Microsoft JhengHei"/>
+        <a:font script="Java" typeface="Javanese Text"/>
+        <a:font script="Lisu" typeface="Segoe UI"/>
+        <a:font script="Mymr" typeface="Myanmar Text"/>
+        <a:font script="Nkoo" typeface="Ebrima"/>
+        <a:font script="Olck" typeface="Nirmala UI"/>
+        <a:font script="Osma" typeface="Ebrima"/>
+        <a:font script="Phag" typeface="Phagspa"/>
+        <a:font script="Syrn" typeface="Estrangelo Edessa"/>
+        <a:font script="Syrj" typeface="Estrangelo Edessa"/>
+        <a:font script="Syre" typeface="Estrangelo Edessa"/>
+        <a:font script="Sora" typeface="Nirmala UI"/>
+        <a:font script="Tale" typeface="Microsoft Tai Le"/>
+        <a:font script="Talu" typeface="Microsoft New Tai Lue"/>
+        <a:font script="Tfng" typeface="Ebrima"/>
+      </a:minorFont>
+    </a:fontScheme>
+    <a:fmtScheme name="Office">
+      <a:fillStyleLst>
+        <a:solidFill>
+          <a:schemeClr val="phClr"/>
+        </a:solidFill>
+        <a:gradFill rotWithShape="1">
+          <a:gsLst>
+            <a:gs pos="0">
+              <a:schemeClr val="phClr">
+                <a:lumMod val="110000"/>
+                <a:satMod val="105000"/>
+                <a:tint val="67000"/>
+              </a:schemeClr>
+            </a:gs>
+            <a:gs pos="50000">
+              <a:schemeClr val="phClr">
+                <a:lumMod val="105000"/>
+                <a:satMod val="103000"/>
+                <a:tint val="73000"/>
+              </a:schemeClr>
+            </a:gs>
+            <a:gs pos="100000">
+              <a:schemeClr val="phClr">
+                <a:lumMod val="105000"/>
+                <a:satMod val="109000"/>
+                <a:tint val="81000"/>
+              </a:schemeClr>
+            </a:gs>
+          </a:gsLst>
+          <a:lin ang="5400000" scaled="0"/>
+        </a:gradFill>
+        <a:gradFill rotWithShape="1">
+          <a:gsLst>
+            <a:gs pos="0">
+              <a:schemeClr val="phClr">
+                <a:satMod val="103000"/>
+                <a:lumMod val="102000"/>
+                <a:tint val="94000"/>
+              </a:schemeClr>
+            </a:gs>
+            <a:gs pos="50000">
+              <a:schemeClr val="phClr">
+                <a:satMod val="110000"/>
+                <a:lumMod val="100000"/>
+                <a:shade val="100000"/>
+              </a:schemeClr>
+            </a:gs>
+            <a:gs pos="100000">
+              <a:schemeClr val="phClr">
+                <a:lumMod val="99000"/>
+                <a:satMod val="120000"/>
+                <a:shade val="78000"/>
+              </a:schemeClr>
+            </a:gs>
+          </a:gsLst>
+          <a:lin ang="5400000" scaled="0"/>
+        </a:gradFill>
+      </a:fillStyleLst>
+      <a:lnStyleLst>
+        <a:ln w="12700" cap="flat" cmpd="sng" algn="ctr">
+          <a:solidFill>
+            <a:schemeClr val="phClr"/>
+          </a:solidFill>
+          <a:prstDash val="solid"/>
+          <a:miter lim="800000"/>
+        </a:ln>
+        <a:ln w="19050" cap="flat" cmpd="sng" algn="ctr">
+          <a:solidFill>
+            <a:schemeClr val="phClr"/>
+          </a:solidFill>
+          <a:prstDash val="solid"/>
+          <a:miter lim="800000"/>
+        </a:ln>
+        <a:ln w="25400" cap="flat" cmpd="sng" algn="ctr">
+          <a:solidFill>
+            <a:schemeClr val="phClr"/>
+          </a:solidFill>
+          <a:prstDash val="solid"/>
+          <a:miter lim="800000"/>
+        </a:ln>
+      </a:lnStyleLst>
+      <a:effectStyleLst>
+        <a:effectStyle>
+          <a:effectLst/>
+        </a:effectStyle>
+        <a:effectStyle>
+          <a:effectLst/>
+        </a:effectStyle>
+        <a:effectStyle>
+          <a:effectLst>
+            <a:outerShdw blurRad="57150" dist="19050" dir="5400000" algn="ctr" rotWithShape="0">
+              <a:srgbClr val="000000">
+                <a:alpha val="63000"/>
+              </a:srgbClr>
+            </a:outerShdw>
+          </a:effectLst>
+        </a:effectStyle>
+      </a:effectStyleLst>
+      <a:bgFillStyleLst>
+        <a:solidFill>
+          <a:schemeClr val="phClr"/>
+        </a:solidFill>
+        <a:solidFill>
+          <a:schemeClr val="phClr">
+            <a:tint val="95000"/>
+            <a:satMod val="170000"/>
+          </a:schemeClr>
+        </a:solidFill>
+        <a:gradFill rotWithShape="1">
+          <a:gsLst>
+            <a:gs pos="0">
+              <a:schemeClr val="phClr">
+                <a:tint val="93000"/>
+                <a:satMod val="150000"/>
+                <a:shade val="98000"/>
+                <a:lumMod val="102000"/>
+              </a:schemeClr>
+            </a:gs>
+            <a:gs pos="50000">
+              <a:schemeClr val="phClr">
+                <a:tint val="98000"/>
+                <a:satMod val="130000"/>
+                <a:shade val="90000"/>
+                <a:lumMod val="103000"/>
+              </a:schemeClr>
+            </a:gs>
+            <a:gs pos="100000">
+              <a:schemeClr val="phClr">
+                <a:shade val="63000"/>
+                <a:satMod val="120000"/>
+              </a:schemeClr>
+            </a:gs>
+          </a:gsLst>
+          <a:lin ang="5400000" scaled="0"/>
+        </a:gradFill>
+      </a:bgFillStyleLst>
+    </a:fmtScheme>
+  </a:themeElements>
+  <a:objectDefaults>
+    <a:lnDef>
+      <a:spPr/>
+      <a:bodyPr/>
+      <a:lstStyle/>
+      <a:style>
+        <a:lnRef idx="2">
+          <a:schemeClr val="accent1"/>
+        </a:lnRef>
+        <a:fillRef idx="0">
+          <a:schemeClr val="accent1"/>
+        </a:fillRef>
+        <a:effectRef idx="1">
+          <a:schemeClr val="accent1"/>
+        </a:effectRef>
+        <a:fontRef idx="minor">
+          <a:schemeClr val="tx1"/>
+        </a:fontRef>
+      </a:style>
+    </a:lnDef>
+  </a:objectDefaults>
+  <a:extraClrSchemeLst/>
+  <a:extLst>
+    <a:ext uri="{05A4C25C-085E-4340-85A3-A5531E510DB2}">
+      <thm15:themeFamily xmlns:thm15="http://schemas.microsoft.com/office/thememl/2012/main" name="Office Theme" id="{2E142A2C-CD16-42D6-873A-C26D2A0506FA}" vid="{1BDDFF52-6CD6-40A5-AB3C-68EB2F1E4D0A}"/>
+    </a:ext>
+  </a:extLst>
+</a:theme>
 </file>
</xml_diff>